<commit_message>
Revise human sentience study and align presentation
</commit_message>
<xml_diff>
--- a/Studies/Why-Humans-Are-Not-Just-Material/Why-Humans-Are-Not-Just-Material.pptx
+++ b/Studies/Why-Humans-Are-Not-Just-Material/Why-Humans-Are-Not-Just-Material.pptx
@@ -2,130 +2,35 @@
 <file path=ppt/presentation.xml><?xml version="1.0" encoding="utf-8"?>
 <p:presentation xmlns:p="http://schemas.openxmlformats.org/presentationml/2006/main">
   <p:sldMasterIdLst>
-    <p:sldMasterId xmlns:r="http://schemas.openxmlformats.org/officeDocument/2006/relationships" id="2147483648" r:id="R18621d12cc4e409b"/>
+    <p:sldMasterId xmlns:r="http://schemas.openxmlformats.org/officeDocument/2006/relationships" id="2147483648" r:id="R2fa9d1eeec7942ca"/>
   </p:sldMasterIdLst>
   <p:notesMasterIdLst>
-    <p:notesMasterId xmlns:r="http://schemas.openxmlformats.org/officeDocument/2006/relationships" r:id="R3eea6ec7d3254456"/>
+    <p:notesMasterId xmlns:r="http://schemas.openxmlformats.org/officeDocument/2006/relationships" r:id="Reb5cbde876594e4b"/>
   </p:notesMasterIdLst>
   <p:sldIdLst>
-    <p:sldId xmlns:r="http://schemas.openxmlformats.org/officeDocument/2006/relationships" id="256" r:id="Rb353911ba8734f24"/>
-    <p:sldId xmlns:r="http://schemas.openxmlformats.org/officeDocument/2006/relationships" id="257" r:id="Re706ca4b49b64453"/>
-    <p:sldId xmlns:r="http://schemas.openxmlformats.org/officeDocument/2006/relationships" id="258" r:id="Rd8366c7b1a2f44f7"/>
-    <p:sldId xmlns:r="http://schemas.openxmlformats.org/officeDocument/2006/relationships" id="259" r:id="R34231c4698254f34"/>
-    <p:sldId xmlns:r="http://schemas.openxmlformats.org/officeDocument/2006/relationships" id="260" r:id="Rd5a506d0f4ad4693"/>
-    <p:sldId xmlns:r="http://schemas.openxmlformats.org/officeDocument/2006/relationships" id="261" r:id="R9d86545f38f64071"/>
-    <p:sldId xmlns:r="http://schemas.openxmlformats.org/officeDocument/2006/relationships" id="262" r:id="R47224349f14e4810"/>
-    <p:sldId xmlns:r="http://schemas.openxmlformats.org/officeDocument/2006/relationships" id="263" r:id="R93564d127d7240ca"/>
-    <p:sldId xmlns:r="http://schemas.openxmlformats.org/officeDocument/2006/relationships" id="264" r:id="R51fa976214054bed"/>
-    <p:sldId xmlns:r="http://schemas.openxmlformats.org/officeDocument/2006/relationships" id="265" r:id="R75473de9f1e54a0c"/>
-    <p:sldId xmlns:r="http://schemas.openxmlformats.org/officeDocument/2006/relationships" id="266" r:id="R929a5f15312842ec"/>
-    <p:sldId xmlns:r="http://schemas.openxmlformats.org/officeDocument/2006/relationships" id="267" r:id="R6d41d63b99d74e51"/>
-    <p:sldId xmlns:r="http://schemas.openxmlformats.org/officeDocument/2006/relationships" id="268" r:id="Rdfdfd9ee2287428a"/>
-    <p:sldId xmlns:r="http://schemas.openxmlformats.org/officeDocument/2006/relationships" id="269" r:id="R73105481d96e42b2"/>
-    <p:sldId xmlns:r="http://schemas.openxmlformats.org/officeDocument/2006/relationships" id="270" r:id="R6b7ddfb8e1f94287"/>
-    <p:sldId xmlns:r="http://schemas.openxmlformats.org/officeDocument/2006/relationships" id="271" r:id="R20a6803db9ed4036"/>
-    <p:sldId xmlns:r="http://schemas.openxmlformats.org/officeDocument/2006/relationships" id="272" r:id="R4c9bbf9ea9ed4e1c"/>
-    <p:sldId xmlns:r="http://schemas.openxmlformats.org/officeDocument/2006/relationships" id="273" r:id="R5e596997d58d4e81"/>
-    <p:sldId xmlns:r="http://schemas.openxmlformats.org/officeDocument/2006/relationships" id="274" r:id="R93502c16feba4b66"/>
-    <p:sldId xmlns:r="http://schemas.openxmlformats.org/officeDocument/2006/relationships" id="275" r:id="Rd16e6a11fc064c49"/>
+    <p:sldId xmlns:r="http://schemas.openxmlformats.org/officeDocument/2006/relationships" id="256" r:id="R6cc567e189ca4888"/>
+    <p:sldId xmlns:r="http://schemas.openxmlformats.org/officeDocument/2006/relationships" id="257" r:id="R260ffa3e65824cba"/>
+    <p:sldId xmlns:r="http://schemas.openxmlformats.org/officeDocument/2006/relationships" id="258" r:id="Rbf27793d33c541e5"/>
+    <p:sldId xmlns:r="http://schemas.openxmlformats.org/officeDocument/2006/relationships" id="259" r:id="R6a6d53fab529485f"/>
+    <p:sldId xmlns:r="http://schemas.openxmlformats.org/officeDocument/2006/relationships" id="260" r:id="Rd8d70905973a4e10"/>
+    <p:sldId xmlns:r="http://schemas.openxmlformats.org/officeDocument/2006/relationships" id="261" r:id="Rcdbeb37bed4046dc"/>
+    <p:sldId xmlns:r="http://schemas.openxmlformats.org/officeDocument/2006/relationships" id="262" r:id="Rc674a5af32e44ca0"/>
+    <p:sldId xmlns:r="http://schemas.openxmlformats.org/officeDocument/2006/relationships" id="263" r:id="R469d39412f504a2a"/>
+    <p:sldId xmlns:r="http://schemas.openxmlformats.org/officeDocument/2006/relationships" id="264" r:id="R8b5cef126dfb4910"/>
+    <p:sldId xmlns:r="http://schemas.openxmlformats.org/officeDocument/2006/relationships" id="265" r:id="R2e0f587d4e304672"/>
+    <p:sldId xmlns:r="http://schemas.openxmlformats.org/officeDocument/2006/relationships" id="266" r:id="R403c16e972254c46"/>
+    <p:sldId xmlns:r="http://schemas.openxmlformats.org/officeDocument/2006/relationships" id="267" r:id="R30bc1274c24847bf"/>
+    <p:sldId xmlns:r="http://schemas.openxmlformats.org/officeDocument/2006/relationships" id="268" r:id="R54d440ec340c4c79"/>
+    <p:sldId xmlns:r="http://schemas.openxmlformats.org/officeDocument/2006/relationships" id="269" r:id="R2b5c1557bca240af"/>
+    <p:sldId xmlns:r="http://schemas.openxmlformats.org/officeDocument/2006/relationships" id="270" r:id="R7ecc506d5adf496d"/>
+    <p:sldId xmlns:r="http://schemas.openxmlformats.org/officeDocument/2006/relationships" id="271" r:id="Rd46bcd89cdc44ef4"/>
+    <p:sldId xmlns:r="http://schemas.openxmlformats.org/officeDocument/2006/relationships" id="272" r:id="Rbf60e6f92b164f8b"/>
+    <p:sldId xmlns:r="http://schemas.openxmlformats.org/officeDocument/2006/relationships" id="273" r:id="Ra495a86748df40ea"/>
+    <p:sldId xmlns:r="http://schemas.openxmlformats.org/officeDocument/2006/relationships" id="274" r:id="Rf9d5b2b90cb94ed6"/>
+    <p:sldId xmlns:r="http://schemas.openxmlformats.org/officeDocument/2006/relationships" id="275" r:id="R97069bd4ece54f0d"/>
   </p:sldIdLst>
   <p:sldSz cx="12191695" cy="6858000"/>
   <p:notesSz cx="6858000" cy="9144000"/>
-  <p:defaultTextStyle>
-    <a:defPPr xmlns:a="http://schemas.openxmlformats.org/drawingml/2006/main">
-      <a:defRPr lang="en-US"/>
-    </a:defPPr>
-    <a:lvl1pPr xmlns:a="http://schemas.openxmlformats.org/drawingml/2006/main" marL="0" indent="0" algn="l" defTabSz="914400">
-      <a:defRPr sz="1800" kern="1200">
-        <a:solidFill>
-          <a:schemeClr val="tx1"/>
-        </a:solidFill>
-        <a:latin typeface="+mn-lt"/>
-        <a:ea typeface="+mn-ea"/>
-        <a:cs typeface="+mn-cs"/>
-      </a:defRPr>
-    </a:lvl1pPr>
-    <a:lvl2pPr xmlns:a="http://schemas.openxmlformats.org/drawingml/2006/main" marL="457200" indent="0" algn="l" defTabSz="914400">
-      <a:defRPr sz="1800" kern="1200">
-        <a:solidFill>
-          <a:schemeClr val="tx1"/>
-        </a:solidFill>
-        <a:latin typeface="+mn-lt"/>
-        <a:ea typeface="+mn-ea"/>
-        <a:cs typeface="+mn-cs"/>
-      </a:defRPr>
-    </a:lvl2pPr>
-    <a:lvl3pPr xmlns:a="http://schemas.openxmlformats.org/drawingml/2006/main" marL="914400" indent="0" algn="l" defTabSz="914400">
-      <a:defRPr sz="1800" kern="1200">
-        <a:solidFill>
-          <a:schemeClr val="tx1"/>
-        </a:solidFill>
-        <a:latin typeface="+mn-lt"/>
-        <a:ea typeface="+mn-ea"/>
-        <a:cs typeface="+mn-cs"/>
-      </a:defRPr>
-    </a:lvl3pPr>
-    <a:lvl4pPr xmlns:a="http://schemas.openxmlformats.org/drawingml/2006/main" marL="1371600" indent="0" algn="l" defTabSz="914400">
-      <a:defRPr sz="1800" kern="1200">
-        <a:solidFill>
-          <a:schemeClr val="tx1"/>
-        </a:solidFill>
-        <a:latin typeface="+mn-lt"/>
-        <a:ea typeface="+mn-ea"/>
-        <a:cs typeface="+mn-cs"/>
-      </a:defRPr>
-    </a:lvl4pPr>
-    <a:lvl5pPr xmlns:a="http://schemas.openxmlformats.org/drawingml/2006/main" marL="1828800" indent="0" algn="l" defTabSz="914400">
-      <a:defRPr sz="1800" kern="1200">
-        <a:solidFill>
-          <a:schemeClr val="tx1"/>
-        </a:solidFill>
-        <a:latin typeface="+mn-lt"/>
-        <a:ea typeface="+mn-ea"/>
-        <a:cs typeface="+mn-cs"/>
-      </a:defRPr>
-    </a:lvl5pPr>
-    <a:lvl6pPr xmlns:a="http://schemas.openxmlformats.org/drawingml/2006/main" marL="2286000" indent="0" algn="l" defTabSz="914400">
-      <a:defRPr sz="1800" kern="1200">
-        <a:solidFill>
-          <a:schemeClr val="tx1"/>
-        </a:solidFill>
-        <a:latin typeface="+mn-lt"/>
-        <a:ea typeface="+mn-ea"/>
-        <a:cs typeface="+mn-cs"/>
-      </a:defRPr>
-    </a:lvl6pPr>
-    <a:lvl7pPr xmlns:a="http://schemas.openxmlformats.org/drawingml/2006/main" marL="2743200" indent="0" algn="l" defTabSz="914400">
-      <a:defRPr sz="1800" kern="1200">
-        <a:solidFill>
-          <a:schemeClr val="tx1"/>
-        </a:solidFill>
-        <a:latin typeface="+mn-lt"/>
-        <a:ea typeface="+mn-ea"/>
-        <a:cs typeface="+mn-cs"/>
-      </a:defRPr>
-    </a:lvl7pPr>
-    <a:lvl8pPr xmlns:a="http://schemas.openxmlformats.org/drawingml/2006/main" marL="3200400" indent="0" algn="l" defTabSz="914400">
-      <a:defRPr sz="1800" kern="1200">
-        <a:solidFill>
-          <a:schemeClr val="tx1"/>
-        </a:solidFill>
-        <a:latin typeface="+mn-lt"/>
-        <a:ea typeface="+mn-ea"/>
-        <a:cs typeface="+mn-cs"/>
-      </a:defRPr>
-    </a:lvl8pPr>
-    <a:lvl9pPr xmlns:a="http://schemas.openxmlformats.org/drawingml/2006/main" marL="3657600" indent="0" algn="l" defTabSz="914400">
-      <a:defRPr sz="1800" kern="1200">
-        <a:solidFill>
-          <a:schemeClr val="tx1"/>
-        </a:solidFill>
-        <a:latin typeface="+mn-lt"/>
-        <a:ea typeface="+mn-ea"/>
-        <a:cs typeface="+mn-cs"/>
-      </a:defRPr>
-    </a:lvl9pPr>
-  </p:defaultTextStyle>
 </p:presentation>
 </file>
 
@@ -579,7 +484,17 @@
           <a:lstStyle xmlns:a="http://schemas.openxmlformats.org/drawingml/2006/main"/>
           <a:p xmlns:a="http://schemas.openxmlformats.org/drawingml/2006/main">
             <a:r>
-              <a:t>This companion deck follows the study 'Why Humans Are Not Just Material.' The question is deliberately concrete: is a human being nothing more than a physical-chemical body? The deck gives three answers - Madhyasth Darshan, mainstream science, and Advaita Vedanta - in a strictly parallel structure, then compares and critically reviews all three.</a:t>
+              <a:t>This companion deck follows the study “Why Humans Are Not Just Material.” Its title expresses the affirmative case being developed: human experience deserves a fuller account than a description of bodily mechanisms alone. The study is open to what inquiry may establish. The further claim that experience requires a distinct, enduring jeevan is the Madhyasth proposal to examine, not a result already demonstrated by the title.</a:t>
+            </a:r>
+          </a:p>
+          <a:p xmlns:a="http://schemas.openxmlformats.org/drawingml/2006/main">
+            <a:r>
+              <a:t/>
+            </a:r>
+          </a:p>
+          <a:p xmlns:a="http://schemas.openxmlformats.org/drawingml/2006/main">
+            <a:r>
+              <a:t>The comparison separates scientific findings from physicalist interpretations of those findings. Madhyasth Darshan, physicalism, and Advaita offer different accounts of the person; scientific methods supply evidence relevant to all of them. The shared approach is to understand each account in its own terms, reason from experience, and ask what can be independently checked. See the study introduction and “How we work” on the Studies landing page.</a:t>
             </a:r>
           </a:p>
         </p:txBody>
@@ -649,7 +564,27 @@
           <a:lstStyle xmlns:a="http://schemas.openxmlformats.org/drawingml/2006/main"/>
           <a:p xmlns:a="http://schemas.openxmlformats.org/drawingml/2006/main">
             <a:r>
-              <a:t>The argument: different functions imply distinct bearers, so a human is a joint form, not a body. The knowledge order's unique work is to understand, evaluate, and responsibly use all of nature - the unfolding of knowledge occurs only through awakened jeevan, with the brain as medium. The koshas will reappear when Advaita negates them.</a:t>
+              <a:t>The different roles are part of the Madhyasth account: they illustrate why it distinguishes body and jeevan. Different functions do not logically require separate entities. A single organised system can support different functions, so that inference would need further premises and evidence.</a:t>
+            </a:r>
+          </a:p>
+          <a:p xmlns:a="http://schemas.openxmlformats.org/drawingml/2006/main">
+            <a:r>
+              <a:t/>
+            </a:r>
+          </a:p>
+          <a:p xmlns:a="http://schemas.openxmlformats.org/drawingml/2006/main">
+            <a:r>
+              <a:t>Sensitivity belongs to the joint form. Jeevan Vidya says a constructed human body without jeevan cannot evidence sensitivity, let alone conscience. It would therefore misstate this account to assign felt sensitivity to the body alone and reserve jeevan only for reflective understanding. The body provides the organs and neural medium; jeevan is the sentient participant. MVD speaks of the brain's receiving signals from hopes, thoughts, desires, resoluteness, and authenticity. These descriptions specify roles while leaving the measurable relation to neural activity unresolved.</a:t>
+            </a:r>
+          </a:p>
+          <a:p xmlns:a="http://schemas.openxmlformats.org/drawingml/2006/main">
+            <a:r>
+              <a:t/>
+            </a:r>
+          </a:p>
+          <a:p xmlns:a="http://schemas.openxmlformats.org/drawingml/2006/main">
+            <a:r>
+              <a:t>The five koshas are not a one-to-one match with Advaita's sheaths; their functions and philosophical use differ. Sources: SB, chapter 7, PDF p. 92, for the displayed quotation (a sentence fragment capitalised at the start); JV, printed p. 37 (PDF position 38); MVD, printed pp. 49–50 and 83–84 (same PDF positions). See study §§1.3.3–1.3.5.</a:t>
             </a:r>
           </a:p>
         </p:txBody>
@@ -719,7 +654,27 @@
           <a:lstStyle xmlns:a="http://schemas.openxmlformats.org/drawingml/2006/main"/>
           <a:p xmlns:a="http://schemas.openxmlformats.org/drawingml/2006/main">
             <a:r>
-              <a:t>Science denies categorical orders, a constitutional sentient atom, and any entity over and above brain-and-body organisation. Each reply maps to one of Madhyasth Darshan's five ontological steps. 'Unique' (human cognition) is not 'non-physical' - it is what brains plus cumulative culture do.</a:t>
+              <a:t>Physicalism interprets mental life as the activity of an embodied organism. The scientific findings strongly support dependence on brain organisation; the further claim that no distinct sentient unit exists is philosophical. Scientific method does not begin by disproving every alternative ontology. The questions here ask the Madhyasth account to connect its classifications and proposed unit to evidence.</a:t>
+            </a:r>
+          </a:p>
+          <a:p xmlns:a="http://schemas.openxmlformats.org/drawingml/2006/main">
+            <a:r>
+              <a:t/>
+            </a:r>
+          </a:p>
+          <a:p xmlns:a="http://schemas.openxmlformats.org/drawingml/2006/main">
+            <a:r>
+              <a:t>Unresponsiveness must be interpreted carefully. Bodien and colleagues detected command-following through EEG or fMRI in 60 of 241 participants who showed no observable command response in a selected clinical sample. This is evidence of covert cognitive capacity through measured brain activity, not evidence of cognition without a functioning brain; it is not a general population prevalence estimate. The DREAM database gathers 2,643 awakenings from 505 participants across 20 datasets. Reports about sleep must distinguish absence of recalled experience from demonstrated absence of experience. Reversible arrest and absent responsiveness also differ from irreversible brain destruction.</a:t>
+            </a:r>
+          </a:p>
+          <a:p xmlns:a="http://schemas.openxmlformats.org/drawingml/2006/main">
+            <a:r>
+              <a:t/>
+            </a:r>
+          </a:p>
+          <a:p xmlns:a="http://schemas.openxmlformats.org/drawingml/2006/main">
+            <a:r>
+              <a:t>Sources: Bodien et al. (2024), https://www.nejm.org/doi/full/10.1056/NEJMoa2400645 ; Wong et al. (2025), https://www.nature.com/articles/s41467-025-61945-1 . See study §§2.3–2.4.</a:t>
             </a:r>
           </a:p>
         </p:txBody>
@@ -789,7 +744,27 @@
           <a:lstStyle xmlns:a="http://schemas.openxmlformats.org/drawingml/2006/main"/>
           <a:p xmlns:a="http://schemas.openxmlformats.org/drawingml/2006/main">
             <a:r>
-              <a:t>This is the sharpest scientific objection and the study states it without flinching. Madhyasth Darshan's joint-form reading models coordination as state and order transmission, not energy injection - but the study concedes this remains an open problem, cross-referenced to the Ontology and Knowledge studies.</a:t>
+              <a:t>The sources describe coordination through signals, but the study has no measured model of those signals. Calling the relation a joint form does not specify how a difference in jeevan produces a difference in neural activity. A useful account must relate its proposed states to observable bodily effects and say how its predictions differ from those of an embodied neural account.</a:t>
+            </a:r>
+          </a:p>
+          <a:p xmlns:a="http://schemas.openxmlformats.org/drawingml/2006/main">
+            <a:r>
+              <a:t/>
+            </a:r>
+          </a:p>
+          <a:p xmlns:a="http://schemas.openxmlformats.org/drawingml/2006/main">
+            <a:r>
+              <a:t>The causal exclusion challenge is conditional. It becomes sharp if bodily effects already have sufficient physical causes, jeevan supplies a distinct sufficient cause, and systematic causal overdetermination is excluded. A defender can contest one of those premises, but should state which one. Energy conservation alone does not establish that every bodily event has a sufficient physical cause. Conversely, not forming chemical bonds would not imply that an entity cannot interact at all. The physical meaning of the source terms needs to be specified before they can be tested as claims about mass or coupling.</a:t>
+            </a:r>
+          </a:p>
+          <a:p xmlns:a="http://schemas.openxmlformats.org/drawingml/2006/main">
+            <a:r>
+              <a:t/>
+            </a:r>
+          </a:p>
+          <a:p xmlns:a="http://schemas.openxmlformats.org/drawingml/2006/main">
+            <a:r>
+              <a:t>Sources: MVD, printed pp. 83–84 and 91 (same PDF positions); Arnadottir and Crane, “There Is No Exclusion Problem,” author manuscript, https://philpapers.org/archive/CRATIN-4.pdf . See study §2.3.3, §5.1, and Editorial Notes.</a:t>
             </a:r>
           </a:p>
         </p:txBody>
@@ -859,7 +834,37 @@
           <a:lstStyle xmlns:a="http://schemas.openxmlformats.org/drawingml/2006/main"/>
           <a:p xmlns:a="http://schemas.openxmlformats.org/drawingml/2006/main">
             <a:r>
-              <a:t>The hard problem is the honest open edge of the scientific account. Panpsychism shows 'sentience in matter' is not a lone mystic's idea - but it is not established science. Madhyasth Darshan's rahasyata is a different epistemic bet: mystery is removable through study and aligned reflection, not a permanent opacity.</a:t>
+              <a:t>Here is the affirmative philosophical case. A description of neural mechanisms can explain discrimination, access, memory, and report while still leaving the question of why there is a felt experience. The knowledge argument sharpens this: if someone acquires every physical fact about colour and later sees red, have they learned a further fact, or gained a new ability or way of encountering a fact? The physicalist reply needs to answer that question; the argument does not simply settle it.</a:t>
+            </a:r>
+          </a:p>
+          <a:p xmlns:a="http://schemas.openxmlformats.org/drawingml/2006/main">
+            <a:r>
+              <a:t/>
+            </a:r>
+          </a:p>
+          <a:p xmlns:a="http://schemas.openxmlformats.org/drawingml/2006/main">
+            <a:r>
+              <a:t>Experience also presents a world whose contents belong together. This places a demand on a theory of the subject. It does not establish an indivisible atom: integration might be realised through distributed and changing processes. Finally, people assess whether beliefs follow from reasons and actions answer to values. A causal explanation needs room for those distinctions. Naturalistic accounts of learning, error correction, and reasoning are serious replies, not the claim that reasoning is blind motion. These considerations motivate going beyond an account that omits experience; moving from them to a specific jeevan needs further argument.</a:t>
+            </a:r>
+          </a:p>
+          <a:p xmlns:a="http://schemas.openxmlformats.org/drawingml/2006/main">
+            <a:r>
+              <a:t/>
+            </a:r>
+          </a:p>
+          <a:p xmlns:a="http://schemas.openxmlformats.org/drawingml/2006/main">
+            <a:r>
+              <a:t>COGITATE's 2025 adversarial study tested specified predictions of integrated information theory and global neuronal workspace theory in 256 participants. Its mixed results challenged parts of both theories; they did not reject every neural explanation or establish a nonmaterial bearer. MD's claim that mystery can be removed through understanding is distinct from this debate's hard problem.</a:t>
+            </a:r>
+          </a:p>
+          <a:p xmlns:a="http://schemas.openxmlformats.org/drawingml/2006/main">
+            <a:r>
+              <a:t/>
+            </a:r>
+          </a:p>
+          <a:p xmlns:a="http://schemas.openxmlformats.org/drawingml/2006/main">
+            <a:r>
+              <a:t>Sources: Chalmers (2003), https://consc.net/papers/nature.html ; Bayne and Chalmers (2003), https://consc.net/papers/unity.html ; Graziano (2024), https://pmc.ncbi.nlm.nih.gov/articles/PMC11521794/ ; COGITATE Consortium (2025), https://www.nature.com/articles/s41586-025-08888-1 . See study §§4.2–4.5 and 2.5.</a:t>
             </a:r>
           </a:p>
         </p:txBody>
@@ -929,7 +934,27 @@
           <a:lstStyle xmlns:a="http://schemas.openxmlformats.org/drawingml/2006/main"/>
           <a:p xmlns:a="http://schemas.openxmlformats.org/drawingml/2006/main">
             <a:r>
-              <a:t>Advaita cuts deeper than joint form: not only is the body not the self, the mind and inner functionary (MD's jeevan) are also observable, hence not-self. The question is not answered but dissolved - there is ultimately no separate human and no independent material world.</a:t>
+              <a:t>Advaita distinguishes the empirical person from the ultimate Self. At the empirical level, bodies, minds, knowledge, ethical practice, and suffering matter. At the ultimate level, awareness is nondual and not one individual subject among many. Mithya means dependent reality here, not that ordinary experience is simply nonexistent.</a:t>
+            </a:r>
+          </a:p>
+          <a:p xmlns:a="http://schemas.openxmlformats.org/drawingml/2006/main">
+            <a:r>
+              <a:t/>
+            </a:r>
+          </a:p>
+          <a:p xmlns:a="http://schemas.openxmlformats.org/drawingml/2006/main">
+            <a:r>
+              <a:t>Distinguishing a witnessed object from awareness begins the inquiry, but does not by itself establish that all awareness is one Brahman. Advaita joins it with Upanishadic testimony and reasoning. A physicalist can question whether a system's capacity to represent its own states requires an ontologically separate witness. Madhyasth Darshan can accept the experienced distinction while affirming many enduring sentient units and a real plural world. These differences should remain clear without making the empirical world disappear rhetorically.</a:t>
+            </a:r>
+          </a:p>
+          <a:p xmlns:a="http://schemas.openxmlformats.org/drawingml/2006/main">
+            <a:r>
+              <a:t/>
+            </a:r>
+          </a:p>
+          <a:p xmlns:a="http://schemas.openxmlformats.org/drawingml/2006/main">
+            <a:r>
+              <a:t>Sources: Brihadaranyaka Upanishad 2.3.6 and 2.4.5; Taittiriya Upanishad 2.1–2.5; Vivekachudamani v. 120, with the authorship qualification in the study's Editorial Notes. See study §3.3.</a:t>
             </a:r>
           </a:p>
         </p:txBody>
@@ -999,7 +1024,27 @@
           <a:lstStyle xmlns:a="http://schemas.openxmlformats.org/drawingml/2006/main"/>
           <a:p xmlns:a="http://schemas.openxmlformats.org/drawingml/2006/main">
             <a:r>
-              <a:t>The test begins with self-verification precisely because the phenomenological argument is checkable by anyone. But conduct closes the chain: understanding must be livable and conveyable. Whether that criterion can be operationalised in a controlled test is flagged as unsettled - the study does not overclaim.</a:t>
+              <a:t>The proposed path starts with the communicated discovery, proceeds through understanding, and looks for evidence in living and communicating that understanding. Nagraj distinguishes samadhi from the samyama through which he reports the discovery. A learner is invited to test the account rather than merely repeat it. In this account, reliable conduct, productive participation, and the ability to convey understanding matter.</a:t>
+            </a:r>
+          </a:p>
+          <a:p xmlns:a="http://schemas.openxmlformats.org/drawingml/2006/main">
+            <a:r>
+              <a:t/>
+            </a:r>
+          </a:p>
+          <a:p xmlns:a="http://schemas.openxmlformats.org/drawingml/2006/main">
+            <a:r>
+              <a:t>A fair practical test would state the learning conditions, compare suitable groups, track outcomes over time, and allow failure to count against a claim. Improvements in trust, justice, or mutual fulfilment would support the practical value of what was learned. They would not by themselves demonstrate the atomic constitution of jeevan or its survival after bodily death. Comparable improvement through a rival programme would matter to any claim of a distinctive practical effect. See study §5 for the separate requirements on practical and ontological claims.</a:t>
+            </a:r>
+          </a:p>
+          <a:p xmlns:a="http://schemas.openxmlformats.org/drawingml/2006/main">
+            <a:r>
+              <a:t/>
+            </a:r>
+          </a:p>
+          <a:p xmlns:a="http://schemas.openxmlformats.org/drawingml/2006/main">
+            <a:r>
+              <a:t>Sources: MVD, printed p. 12 (PDF position 12); JV, printed pp. 24–27 (PDF positions 25–28); study §§1.4 and 5.1.</a:t>
             </a:r>
           </a:p>
         </p:txBody>
@@ -1069,7 +1114,17 @@
           <a:lstStyle xmlns:a="http://schemas.openxmlformats.org/drawingml/2006/main"/>
           <a:p xmlns:a="http://schemas.openxmlformats.org/drawingml/2006/main">
             <a:r>
-              <a:t>The grid lines up the three views on the questions that matter. Reading across any row shows exactly where they part company - the middle column (Madhyasth Darshan) holds the middle position on almost every row: a real self AND a real world.</a:t>
+              <a:t>The rows compare commitments, not equally established findings. In the first column, physicalism is the interpretation being compared; science supplies evidence such as neural dependence. Physicalism can recognise many persons and preserve psychological and social explanations while holding that persons are wholly physical.</a:t>
+            </a:r>
+          </a:p>
+          <a:p xmlns:a="http://schemas.openxmlformats.org/drawingml/2006/main">
+            <a:r>
+              <a:t/>
+            </a:r>
+          </a:p>
+          <a:p xmlns:a="http://schemas.openxmlformats.org/drawingml/2006/main">
+            <a:r>
+              <a:t>Madhyasth Darshan describes each living human as one body joined with one jeevan; the account has many jeevans across persons, not many within a single human. Advaita accepts plurality in empirical life while denying separate ultimate selves. The survival row also compares different claims: continued individual jeevan differs from the claim that the nondual Self never begins or ends. A position's place in the middle of a table gives it no evidential advantage. See study §4.1.</a:t>
             </a:r>
           </a:p>
         </p:txBody>
@@ -1139,7 +1194,17 @@
           <a:lstStyle xmlns:a="http://schemas.openxmlformats.org/drawingml/2006/main"/>
           <a:p xmlns:a="http://schemas.openxmlformats.org/drawingml/2006/main">
             <a:r>
-              <a:t>Each pair of views agrees on something the third denies. This 'alliances' framing is the memorable payoff of the comparison: the debate is not two-sided but triangular, and Madhyasth Darshan's middle position is defined by which alliance it joins on each question.</a:t>
+              <a:t>The overlaps help locate the disagreements, but are not additional arguments for the account at their intersection. Madhyasth Darshan affirms a real shared world and many sentient individuals; Advaita's ultimate nonduality and physicalism's physical constitution each depart from that account in a different way.</a:t>
+            </a:r>
+          </a:p>
+          <a:p xmlns:a="http://schemas.openxmlformats.org/drawingml/2006/main">
+            <a:r>
+              <a:t/>
+            </a:r>
+          </a:p>
+          <a:p xmlns:a="http://schemas.openxmlformats.org/drawingml/2006/main">
+            <a:r>
+              <a:t>What matters is whether the positive account explains experience and survives comparison with evidence. The case from experience, unity, and reasons is developed in study §§4.2–4.5. Those arguments can motivate resistance to an incomplete reduction of the human while leaving open which account of sentience is best supported.</a:t>
             </a:r>
           </a:p>
         </p:txBody>
@@ -1209,7 +1274,17 @@
           <a:lstStyle xmlns:a="http://schemas.openxmlformats.org/drawingml/2006/main"/>
           <a:p xmlns:a="http://schemas.openxmlformats.org/drawingml/2006/main">
             <a:r>
-              <a:t>No view escapes serious objection. Madhyasth Darshan is best read as an internally coherent, ethically rich proposal, not a demonstrated ontology. Science offers the strongest method but its claim to be the complete account is philosophy, not finding. Advaita is the most radical, at the price of demoting the world we live in.</a:t>
+              <a:t>The views face different burdens and do not have equal evidential standing simply because none settles every question. Madhyasth Darshan gives a connected account of experience, understanding, conduct, and coexistence. Its distinctive atomic, causal, and survival commitments need evidence beyond textual agreement or practical benefit. Internal coherence itself must be examined, especially the relation between the transition to sentience and the permanent character subsequently attributed to it.</a:t>
+            </a:r>
+          </a:p>
+          <a:p xmlns:a="http://schemas.openxmlformats.org/drawingml/2006/main">
+            <a:r>
+              <a:t/>
+            </a:r>
+          </a:p>
+          <a:p xmlns:a="http://schemas.openxmlformats.org/drawingml/2006/main">
+            <a:r>
+              <a:t>Neuroscience supplies strong, detailed causal constraints on any account of the person. Physicalism interprets them as consistent with a wholly physical person; whether that gives a complete account of subjective experience remains philosophically disputed. Advaita develops a sustained inquiry into awareness with ethical and contemplative disciplines, while its move from the witness to nondual Brahman depends on further reasoning and scriptural warrant. See study §§5.1–5.3.</a:t>
             </a:r>
           </a:p>
         </p:txBody>
@@ -1279,7 +1354,17 @@
           <a:lstStyle xmlns:a="http://schemas.openxmlformats.org/drawingml/2006/main"/>
           <a:p xmlns:a="http://schemas.openxmlformats.org/drawingml/2006/main">
             <a:r>
-              <a:t>The honest close: the disagreement is philosophical, about what counts as evidence, not a dispute any single experiment resolves. The study names concretely what would move each side - a rare feature in comparative philosophy - and leaves the verdict open.</a:t>
+              <a:t>The disagreement is partly philosophical and partly about claims that owe observable consequences. Jeevan's atomic constitution, its coordination with the body, and its proposed continuation beyond death are not settled by agreeing that experience is difficult to explain. A proposal becomes more informative when it states what should be observed, under what conditions, and what would count against it.</a:t>
+            </a:r>
+          </a:p>
+          <a:p xmlns:a="http://schemas.openxmlformats.org/drawingml/2006/main">
+            <a:r>
+              <a:t/>
+            </a:r>
+          </a:p>
+          <a:p xmlns:a="http://schemas.openxmlformats.org/drawingml/2006/main">
+            <a:r>
+              <a:t>Neural models that increasingly predict and explain fine-grained changes in experience reduce the explanatory work left for a separate unit, although predictive success is not a deductive proof of metaphysical identity. Conversely, a repeatable effect would strengthen the jeevan account only insofar as it distinguishes that account from neurological, psychological, and methodological alternatives. Conduct studies can test practical learning; contemplative studies can test reports and transformation. Neither automatically settles its tradition's full ontology. See study §5.4.</a:t>
             </a:r>
           </a:p>
         </p:txBody>
@@ -1349,7 +1434,17 @@
           <a:lstStyle xmlns:a="http://schemas.openxmlformats.org/drawingml/2006/main"/>
           <a:p xmlns:a="http://schemas.openxmlformats.org/drawingml/2006/main">
             <a:r>
-              <a:t>The standpoint is a scientist-technologist asking the question in good faith, not to defend a foregone conclusion. The three answers disagree at the deepest level - about what a human is, whether the world is real, and what survives death - so the comparison is genuine, not cosmetic.</a:t>
+              <a:t>The question concerns more than the chemistry of a body. It concerns felt experience, a continuing sense of self, the force of reasons, and the aspiration to live well with others. We should first understand why these require explanation, then examine what follows about their bearer.</a:t>
+            </a:r>
+          </a:p>
+          <a:p xmlns:a="http://schemas.openxmlformats.org/drawingml/2006/main">
+            <a:r>
+              <a:t/>
+            </a:r>
+          </a:p>
+          <a:p xmlns:a="http://schemas.openxmlformats.org/drawingml/2006/main">
+            <a:r>
+              <a:t>Physicalism holds that the embodied person is wholly physical. It can retain psychological, social, and ethical explanations without claiming that every useful explanation can be rewritten in the language of physics. Science itself is a collection of methods and findings; it does not simply stipulate this metaphysics. Madhyasth Darshan affirms a material body in joint form with a distinct sentient unit. Advaita distinguishes the empirical person from the ultimate nondual Self. These are substantive differences, including different commitments about individuality, the world, and death. See study §§1.1, 2.1, 3.1.</a:t>
             </a:r>
           </a:p>
         </p:txBody>
@@ -1419,7 +1514,17 @@
           <a:lstStyle xmlns:a="http://schemas.openxmlformats.org/drawingml/2006/main"/>
           <a:p xmlns:a="http://schemas.openxmlformats.org/drawingml/2006/main">
             <a:r>
-              <a:t>Close by returning to the question. The three answers are parallel accounts, each internally coherent and each unproven from outside. Madhyasth Darshan's distinctive contribution is the middle path: a real, sentient self in a real, perpetual world, tested by lived conduct.</a:t>
+              <a:t>The title keeps the study's affirmative motivation. Human experience, the unity of an experienced world, and the responsiveness of belief and action to reasons are substantial things to explain. They give a reason to resist treating a description of bodily machinery as the whole answer before the explanation is supplied.</a:t>
+            </a:r>
+          </a:p>
+          <a:p xmlns:a="http://schemas.openxmlformats.org/drawingml/2006/main">
+            <a:r>
+              <a:t/>
+            </a:r>
+          </a:p>
+          <a:p xmlns:a="http://schemas.openxmlformats.org/drawingml/2006/main">
+            <a:r>
+              <a:t>Madhyasth Darshan offers a distinctive positive account: a real sentient individual in a real shared world, living through a body and capable of understanding and responsible conduct. The stronger conclusion that this requires an enduring, constitutionally complete jeevan remains a proposal to develop and test. Current neuroscience supplies evidence that any such account must explain; it does not by itself answer every metaphysical question. The next step is to sharpen the argument and identify the observations that would support or weaken each of its claims. See study §§4.5 and 5.4.</a:t>
             </a:r>
           </a:p>
         </p:txBody>
@@ -1489,7 +1594,17 @@
           <a:lstStyle xmlns:a="http://schemas.openxmlformats.org/drawingml/2006/main"/>
           <a:p xmlns:a="http://schemas.openxmlformats.org/drawingml/2006/main">
             <a:r>
-              <a:t>Rather than walk each view from start to finish, the deck compares the three on the same axis. First the phenomenological argument — the same lived, first-person experience read three ways (Madhyasth Darshan, science, Advaita). Then the ontological argument — what each says actually exists. Method, comparison, and critical review follow. Leading with lived experience gives the audience the felt sense that a human is more than a body before any metaphysics is introduced.</a:t>
+              <a:t>The sequence begins with experience so that the question stays connected to what needs explaining. Bodily satisfaction, personal fulfilment, selfhood, and moral life are the shared subjects of inquiry. Their presence is not yet a proof of any particular ontology.</a:t>
+            </a:r>
+          </a:p>
+          <a:p xmlns:a="http://schemas.openxmlformats.org/drawingml/2006/main">
+            <a:r>
+              <a:t/>
+            </a:r>
+          </a:p>
+          <a:p xmlns:a="http://schemas.openxmlformats.org/drawingml/2006/main">
+            <a:r>
+              <a:t>We then examine the Madhyasth account in connected form, follow the scientific evidence and physicalist response, and consider Advaita's different use of experience and testimony. The later comparison develops the strongest affirmative arguments from experience, unity, and reasons while considering physicalist replies. The final test is what each argument establishes, which claims go further, and what evidence could change the assessment. This follows the study's approach rather than asking the audience to accept its conclusion in advance.</a:t>
             </a:r>
           </a:p>
         </p:txBody>
@@ -1559,7 +1674,27 @@
           <a:lstStyle xmlns:a="http://schemas.openxmlformats.org/drawingml/2006/main"/>
           <a:p xmlns:a="http://schemas.openxmlformats.org/drawingml/2006/main">
             <a:r>
-              <a:t>Four everyday observations, each available to inward inspection: a second kind of fulfilment, a more-than-bodily wanting, a self presented as distinct from its body, and an unlearned moral demand. Madhyasth Darshan's claim is that materialism fails not only in the lab but in the first person, every day, in everyone.</a:t>
+              <a:t>Madhyasth Darshan draws attention to a difference between satisfying bodily needs and finding fulfilment through understanding, trust, and justice. Its claim about continuous happiness is not the claim that people always seek ever more possessions. Accumulation can express an unsuccessful attempt to satisfy a continuing aspiration.</a:t>
+            </a:r>
+          </a:p>
+          <a:p xmlns:a="http://schemas.openxmlformats.org/drawingml/2006/main">
+            <a:r>
+              <a:t/>
+            </a:r>
+          </a:p>
+          <a:p xmlns:a="http://schemas.openxmlformats.org/drawingml/2006/main">
+            <a:r>
+              <a:t>The experienced distinction between “I” and “my body” raises a question about the self. A continuing person through sleep does not automatically mean uninterrupted reportable experience. Likewise, the source's proposal of an inherent orientation to justice needs to be distinguished from what developmental experiments measure. Early attention to social actions is narrower than understanding justice, and neither by itself identifies jeevan.</a:t>
+            </a:r>
+          </a:p>
+          <a:p xmlns:a="http://schemas.openxmlformats.org/drawingml/2006/main">
+            <a:r>
+              <a:t/>
+            </a:r>
+          </a:p>
+          <a:p xmlns:a="http://schemas.openxmlformats.org/drawingml/2006/main">
+            <a:r>
+              <a:t>Sources: Samadhanatmak Bhautikvad (SB), PDF pp. 15 and 91–92; Jeevan Vidya—An Introduction (JV), printed pp. 24–27 (PDF positions 25–28). Study §1.2 supplies the connected account; §§2.2 and 4 examine alternative explanations and the further argument.</a:t>
             </a:r>
           </a:p>
         </p:txBody>
@@ -1629,7 +1764,27 @@
           <a:lstStyle xmlns:a="http://schemas.openxmlformats.org/drawingml/2006/main"/>
           <a:p xmlns:a="http://schemas.openxmlformats.org/drawingml/2006/main">
             <a:r>
-              <a:t>The four cards answer Madhyasth Darshan's four phenomenological observations one-for-one, each with a material mechanism. Science's warrant is inter-subjective verification, which parallels MD's demand for evidence in conduct but restricts proof to what independent observers can test.</a:t>
+              <a:t>These examples show why the evidence must enter the argument in detail. Lockwood and colleagues studied 25 people with damage to the ventromedial prefrontal cortex alongside lesion and healthy comparison groups. Willingness to exert effort for others was reduced selectively. This is evidence about a component of prosocial motivation, not the disappearance of all value or moral judgement. Lyu and colleagues found that stimulation of the anterior precuneus could alter bodily self-experience in nine patients. Such selective changes constrain a body–jeevan account as well as a physicalist one.</a:t>
+            </a:r>
+          </a:p>
+          <a:p xmlns:a="http://schemas.openxmlformats.org/drawingml/2006/main">
+            <a:r>
+              <a:t/>
+            </a:r>
+          </a:p>
+          <a:p xmlns:a="http://schemas.openxmlformats.org/drawingml/2006/main">
+            <a:r>
+              <a:t>Formal models of learning and active inference offer possible accounts of ongoing goals. They do not establish that all aspirations to lasting happiness have been explained. Geraci and colleagues found a preference for prosocial actions in newborn looking behaviour; the large ManyBabies study reported no reliable helper preference in older infants on a different task. The latter is not a direct replication of the newborn study. Neither finding establishes an entire moral doctrine at birth.</a:t>
+            </a:r>
+          </a:p>
+          <a:p xmlns:a="http://schemas.openxmlformats.org/drawingml/2006/main">
+            <a:r>
+              <a:t/>
+            </a:r>
+          </a:p>
+          <a:p xmlns:a="http://schemas.openxmlformats.org/drawingml/2006/main">
+            <a:r>
+              <a:t>Sources: Lockwood et al. (2024), https://www.nature.com/articles/s41562-024-01899-4 ; Lyu et al. (2023), https://doi.org/10.1016/j.neuron.2023.05.013 ; Friston et al. (2015), https://doi.org/10.1080/17588928.2015.1020053 ; Geraci et al. (2025), https://www.nature.com/articles/s41467-025-61517-3 ; Lucca et al. (2025), https://doi.org/10.1111/desc.13581 . See study §2.2.</a:t>
             </a:r>
           </a:p>
         </p:txBody>
@@ -1699,7 +1854,27 @@
           <a:lstStyle xmlns:a="http://schemas.openxmlformats.org/drawingml/2006/main"/>
           <a:p xmlns:a="http://schemas.openxmlformats.org/drawingml/2006/main">
             <a:r>
-              <a:t>Both Madhyasth Darshan and Advaita begin from the same first-person data - the felt self/body distinction, the sleep observation - but stop at different stations. Advaita's five sheaths are the very koshas MD affirms as functional equipment; Advaita negates them progressively to reveal the witness beyond all layers.</a:t>
+              <a:t>Advaita asks the inquirer to distinguish what is witnessed from the witness. The body, thoughts, desires, and the sense of an individual ego can all become objects of awareness. Within the tradition, this inquiry is joined with Upanishadic teaching, reasoning, and contemplative discipline. It is not simply a psychological exercise that independently demonstrates Brahman.</a:t>
+            </a:r>
+          </a:p>
+          <a:p xmlns:a="http://schemas.openxmlformats.org/drawingml/2006/main">
+            <a:r>
+              <a:t/>
+            </a:r>
+          </a:p>
+          <a:p xmlns:a="http://schemas.openxmlformats.org/drawingml/2006/main">
+            <a:r>
+              <a:t>Its treatment of waking, dream, and deep sleep is a philosophical interpretation of the states. A later report that nothing was remembered does not independently establish either continuous awareness or its absence throughout sleep. Nor does the use of five koshas establish agreement with Madhyasth Darshan. Both accounts use that vocabulary, but assign the layers different functions and roles in liberation or awakening. Describing how Advaita would assess jeevan is our comparison; the classical texts are not directly commenting on Nagraj's theory.</a:t>
+            </a:r>
+          </a:p>
+          <a:p xmlns:a="http://schemas.openxmlformats.org/drawingml/2006/main">
+            <a:r>
+              <a:t/>
+            </a:r>
+          </a:p>
+          <a:p xmlns:a="http://schemas.openxmlformats.org/drawingml/2006/main">
+            <a:r>
+              <a:t>Sources: Drig-Drishya-Viveka vv. 1–5; Brihadaranyaka Upanishad 2.3.6 and 2.4.5; Mandukya Upanishad vv. 3–7; Taittiriya Upanishad 2.1–2.5. See study §§3.2–3.4 and Editorial Notes on textual scope.</a:t>
             </a:r>
           </a:p>
         </p:txBody>
@@ -1769,7 +1944,27 @@
           <a:lstStyle xmlns:a="http://schemas.openxmlformats.org/drawingml/2006/main"/>
           <a:p xmlns:a="http://schemas.openxmlformats.org/drawingml/2006/main">
             <a:r>
-              <a:t>The whole system rests on one ontological claim: existence includes physical, chemical, AND jeevan entities. Madhyasth Darshan rejects both inherited pictures - human-as-clever-animal and human-as-unknowable-mystery - as failures to study the human being as it actually is.</a:t>
+              <a:t>Madhyasth Darshan places the human within a real coexistence of physical, chemical, and jeevan units in Omnipresence. The human body and jeevan form a temporary joint form. The body composes and decomposes; jeevan is said to retain its constitution and capacity for sentience. Sensation and action occur through the embodied joint form, while understanding and evaluation are attributed to jeevan.</a:t>
+            </a:r>
+          </a:p>
+          <a:p xmlns:a="http://schemas.openxmlformats.org/drawingml/2006/main">
+            <a:r>
+              <a:t/>
+            </a:r>
+          </a:p>
+          <a:p xmlns:a="http://schemas.openxmlformats.org/drawingml/2006/main">
+            <a:r>
+              <a:t>This is an affirmative account with commitments of its own, including atomic completion, coordination with a body, and continued existence after bodily death. The claim should be understood as a whole before it is tested. Calling it a sentient atom does not by itself identify it with an atom as defined and measured in present physics. Jeevan Vidya expressly calls jeevan neither physical nor non-physical, but a constitutionally complete sentient atom.</a:t>
+            </a:r>
+          </a:p>
+          <a:p xmlns:a="http://schemas.openxmlformats.org/drawingml/2006/main">
+            <a:r>
+              <a:t/>
+            </a:r>
+          </a:p>
+          <a:p xmlns:a="http://schemas.openxmlformats.org/drawingml/2006/main">
+            <a:r>
+              <a:t>Sources: Madhyasth Darshan Vangmaya (MVD), The Alternative, point 7, printed p. 5 (PDF position 5), for the displayed quotation; JV, printed p. 36 (PDF position 37). See study §§1.1 and 1.3.</a:t>
             </a:r>
           </a:p>
         </p:txBody>
@@ -1839,7 +2034,27 @@
           <a:lstStyle xmlns:a="http://schemas.openxmlformats.org/drawingml/2006/main"/>
           <a:p xmlns:a="http://schemas.openxmlformats.org/drawingml/2006/main">
             <a:r>
-              <a:t>Material and biological orders integrate, grow, and vitalise but have no hope to live. 'Hope to live' enters at the animal order - the threshold where a constitutionally complete sentient unit, the jeevan, appears. In the knowledge order the same jeevan works through a human body as a joint form.</a:t>
+              <a:t>The four orders are distinguished by their characteristic activities and conduct. Material formations compose and decompose. Biological formations grow and reproduce. Animal life is described as a joint form of body and jeevan, with sensitivity and a hope to live. The knowledge order is the human joint form, capable of understanding existence and expressing that understanding in responsible conduct.</a:t>
+            </a:r>
+          </a:p>
+          <a:p xmlns:a="http://schemas.openxmlformats.org/drawingml/2006/main">
+            <a:r>
+              <a:t/>
+            </a:r>
+          </a:p>
+          <a:p xmlns:a="http://schemas.openxmlformats.org/drawingml/2006/main">
+            <a:r>
+              <a:t>The classification is not a claim that four substances are stacked inside the human. Nor is the order sequence by itself a measured evolutionary explanation of how jeevan first appears. Compositional development of bodies and constitutional development of an atom do different work in the account. The human brain is the bodily medium for the expression of understanding; knowledge here must not be confused with a newly acquired capacity for any sentience at all.</a:t>
+            </a:r>
+          </a:p>
+          <a:p xmlns:a="http://schemas.openxmlformats.org/drawingml/2006/main">
+            <a:r>
+              <a:t/>
+            </a:r>
+          </a:p>
+          <a:p xmlns:a="http://schemas.openxmlformats.org/drawingml/2006/main">
+            <a:r>
+              <a:t>Sources: SB, PDF pp. 179–180; MVD, printed pp. 91 and 115–116 (same PDF positions). See study §§1.3.1 and 1.3.4.</a:t>
             </a:r>
           </a:p>
         </p:txBody>
@@ -1909,7 +2124,27 @@
           <a:lstStyle xmlns:a="http://schemas.openxmlformats.org/drawingml/2006/main"/>
           <a:p xmlns:a="http://schemas.openxmlformats.org/drawingml/2006/main">
             <a:r>
-              <a:t>This is the densest step. Core claim first: constitutional completeness is a one-way threshold, and the completed atom IS the jeevan. Sentience is latency actualised, not magic emergence from dead matter. Post-death continuity is a distinct claim, inferred - not read off phenomenology. The heavy machinery lives in the Ontology study.</a:t>
+              <a:t>The diagram is a compact paraphrase of the proposed transition, not a measured physical sequence. An evolving atom exchanges particles. At constitutional completion the source describes a closed constitution, freedom from weight and molecular bondage, and an irreversible change to sentience. Jeevan continues as that constitutionally complete unit. The source also attributes its persistence beyond the death of a body.</a:t>
+            </a:r>
+          </a:p>
+          <a:p xmlns:a="http://schemas.openxmlformats.org/drawingml/2006/main">
+            <a:r>
+              <a:t/>
+            </a:r>
+          </a:p>
+          <a:p xmlns:a="http://schemas.openxmlformats.org/drawingml/2006/main">
+            <a:r>
+              <a:t>The presentation does not add an explanation in which latent sentience becomes actual, or assert that an unembodied jeevan is inactive. Those additions do not resolve the transition described in the texts. Freedom from weight bondage has not been operationally identified with zero rest mass. The source's 122 activities in paired faculty groups also do not by themselves establish a 61-particle constitution. Atomic constitution, persistence, and its coordination with a brain each require a way to distinguish the proposal from alternative accounts. Study §5 sets out those evidential requirements.</a:t>
+            </a:r>
+          </a:p>
+          <a:p xmlns:a="http://schemas.openxmlformats.org/drawingml/2006/main">
+            <a:r>
+              <a:t/>
+            </a:r>
+          </a:p>
+          <a:p xmlns:a="http://schemas.openxmlformats.org/drawingml/2006/main">
+            <a:r>
+              <a:t>Sources: MVD, printed pp. 78, 91 and 323 (same PDF positions); JV, printed pp. 19, 36–37 and 54 (PDF positions 20, 37–38 and 55). Related study The Ontology of Coexistence §6.2.1 discusses public identification, §6.2.2 persistence and the joint form, and §6.2.3 evidence and evolution.</a:t>
             </a:r>
           </a:p>
         </p:txBody>
@@ -4865,17 +5100,17 @@
   </p:cSld>
   <p:clrMap bg1="lt1" tx1="dk1" bg2="lt2" tx2="dk2" accent1="accent1" accent2="accent2" accent3="accent3" accent4="accent4" accent5="accent5" accent6="accent6" hlink="hlink" folHlink="folHlink"/>
   <p:sldLayoutIdLst>
-    <p:sldLayoutId xmlns:r="http://schemas.openxmlformats.org/officeDocument/2006/relationships" id="2147483649" r:id="Rb80b8569113a4d9a"/>
-    <p:sldLayoutId xmlns:r="http://schemas.openxmlformats.org/officeDocument/2006/relationships" id="2147483650" r:id="R68b5ebf037854f46"/>
-    <p:sldLayoutId xmlns:r="http://schemas.openxmlformats.org/officeDocument/2006/relationships" id="2147483651" r:id="Rfb010ed3d3ce4e00"/>
-    <p:sldLayoutId xmlns:r="http://schemas.openxmlformats.org/officeDocument/2006/relationships" id="2147483652" r:id="Rd5e2c591e8c94d09"/>
-    <p:sldLayoutId xmlns:r="http://schemas.openxmlformats.org/officeDocument/2006/relationships" id="2147483653" r:id="R978288bd62f646e4"/>
-    <p:sldLayoutId xmlns:r="http://schemas.openxmlformats.org/officeDocument/2006/relationships" id="2147483654" r:id="Raee95c2632964389"/>
-    <p:sldLayoutId xmlns:r="http://schemas.openxmlformats.org/officeDocument/2006/relationships" id="2147483655" r:id="R6e7e4e88458c44bd"/>
-    <p:sldLayoutId xmlns:r="http://schemas.openxmlformats.org/officeDocument/2006/relationships" id="2147483656" r:id="R0be1e4a869c9441f"/>
-    <p:sldLayoutId xmlns:r="http://schemas.openxmlformats.org/officeDocument/2006/relationships" id="2147483657" r:id="R8d2303170041420a"/>
-    <p:sldLayoutId xmlns:r="http://schemas.openxmlformats.org/officeDocument/2006/relationships" id="2147483658" r:id="R99b68b6dd5194b6d"/>
-    <p:sldLayoutId xmlns:r="http://schemas.openxmlformats.org/officeDocument/2006/relationships" id="2147483659" r:id="R3bd586aad0b64bf0"/>
+    <p:sldLayoutId xmlns:r="http://schemas.openxmlformats.org/officeDocument/2006/relationships" id="2147483649" r:id="Rfe240fa849074ddc"/>
+    <p:sldLayoutId xmlns:r="http://schemas.openxmlformats.org/officeDocument/2006/relationships" id="2147483650" r:id="Rc0c09e65f90344e9"/>
+    <p:sldLayoutId xmlns:r="http://schemas.openxmlformats.org/officeDocument/2006/relationships" id="2147483651" r:id="R17a70069d6874338"/>
+    <p:sldLayoutId xmlns:r="http://schemas.openxmlformats.org/officeDocument/2006/relationships" id="2147483652" r:id="Rc1b009e74c014a28"/>
+    <p:sldLayoutId xmlns:r="http://schemas.openxmlformats.org/officeDocument/2006/relationships" id="2147483653" r:id="R00bd2ec3bc4d4bb5"/>
+    <p:sldLayoutId xmlns:r="http://schemas.openxmlformats.org/officeDocument/2006/relationships" id="2147483654" r:id="R9ed214aeb51e4ee0"/>
+    <p:sldLayoutId xmlns:r="http://schemas.openxmlformats.org/officeDocument/2006/relationships" id="2147483655" r:id="Rfbfb9806a6834862"/>
+    <p:sldLayoutId xmlns:r="http://schemas.openxmlformats.org/officeDocument/2006/relationships" id="2147483656" r:id="Rb47eb73b54aa4ab3"/>
+    <p:sldLayoutId xmlns:r="http://schemas.openxmlformats.org/officeDocument/2006/relationships" id="2147483657" r:id="Re6af7382f8ad4660"/>
+    <p:sldLayoutId xmlns:r="http://schemas.openxmlformats.org/officeDocument/2006/relationships" id="2147483658" r:id="R6326a2798ba64623"/>
+    <p:sldLayoutId xmlns:r="http://schemas.openxmlformats.org/officeDocument/2006/relationships" id="2147483659" r:id="R69f6e68d52c345c6"/>
   </p:sldLayoutIdLst>
   <p:txStyles>
     <p:titleStyle>
@@ -6755,7 +6990,7 @@
                 <a:ea typeface="Calibri"/>
                 <a:cs typeface="Calibri"/>
               </a:rPr>
-              <a:t>Digestion, circulation, and neural activity belong to the body; imagination, appraisal, and understanding are attributed to jeevan. This illustrates the proposal—it does not independently prove two entities.</a:t>
+              <a:t>The body supplies sensory organs and neural processing. Jeevan bears felt experience and evaluation. These roles explain the proposed joint form; they do not by themselves prove two entities.</a:t>
             </a:r>
           </a:p>
         </p:txBody>
@@ -7022,7 +7257,7 @@
                 <a:ea typeface="Cambria"/>
                 <a:cs typeface="Cambria"/>
               </a:rPr>
-              <a:t>Joint form, not a pilot</a:t>
+              <a:t>Sensitivity in the joint form</a:t>
             </a:r>
           </a:p>
         </p:txBody>
@@ -7078,7 +7313,7 @@
                 <a:ea typeface="Calibri"/>
                 <a:cs typeface="Calibri"/>
               </a:rPr>
-              <a:t>MD describes coexistence and mutual participation: neither a ghost pushing matter nor identity of mind with brain. A detailed causal model remains an open requirement.</a:t>
+              <a:t>Sensitivity requires jeevan together with a suitable body. The sources describe the brain as a medium receiving signals from jeevan. How this coordination works remains to be established.</a:t>
             </a:r>
           </a:p>
         </p:txBody>
@@ -7401,7 +7636,7 @@
                 <a:ea typeface="Calibri"/>
                 <a:cs typeface="Calibri"/>
               </a:rPr>
-              <a:t>MD’s bodily and conscious layers can be compared with Advaita’s five sheaths, but the systems differ in number, function, and ontology.</a:t>
+              <a:t>Both accounts use five koshas, but assign them different functions and philosophical roles. Shared vocabulary does not establish a shared model.</a:t>
             </a:r>
           </a:p>
         </p:txBody>
@@ -7877,7 +8112,7 @@
                 <a:ea typeface="Calibri"/>
                 <a:cs typeface="Calibri"/>
               </a:rPr>
-              <a:t>SCIENCE · ONTOLOGY</a:t>
+              <a:t>PHYSICALISM · ONTOLOGY</a:t>
             </a:r>
           </a:p>
         </p:txBody>
@@ -8629,7 +8864,7 @@
                 <a:ea typeface="Calibri"/>
                 <a:cs typeface="Calibri"/>
               </a:rPr>
-              <a:t>Five replies to the Madhyasth ontology</a:t>
+              <a:t>Five questions for the Madhyasth ontology</a:t>
             </a:r>
           </a:p>
         </p:txBody>
@@ -8735,7 +8970,7 @@
                 <a:ea typeface="Cambria"/>
                 <a:cs typeface="Cambria"/>
               </a:rPr>
-              <a:t>Continuity, not four orders</a:t>
+              <a:t>Evolution and the four orders</a:t>
             </a:r>
           </a:p>
         </p:txBody>
@@ -8788,7 +9023,7 @@
                 <a:ea typeface="Calibri"/>
                 <a:cs typeface="Calibri"/>
               </a:rPr>
-              <a:t>Gradients of organisation; no sentient threshold observed</a:t>
+              <a:t>Relate the proposed orders to biological descent</a:t>
             </a:r>
           </a:p>
         </p:txBody>
@@ -8894,7 +9129,7 @@
                 <a:ea typeface="Cambria"/>
                 <a:cs typeface="Cambria"/>
               </a:rPr>
-              <a:t>Mind emerges from organisation</a:t>
+              <a:t>Mental function and organisation</a:t>
             </a:r>
           </a:p>
         </p:txBody>
@@ -8947,7 +9182,7 @@
                 <a:ea typeface="Calibri"/>
                 <a:cs typeface="Calibri"/>
               </a:rPr>
-              <a:t>Destroy the organisation and mental functions cease</a:t>
+              <a:t>Irreversible brain destruction ends observable mental function</a:t>
             </a:r>
           </a:p>
         </p:txBody>
@@ -9212,7 +9447,7 @@
                 <a:ea typeface="Cambria"/>
                 <a:cs typeface="Cambria"/>
               </a:rPr>
-              <a:t>Culture + brain, not a knower</a:t>
+              <a:t>Cognition through brain and culture</a:t>
             </a:r>
           </a:p>
         </p:txBody>
@@ -10463,7 +10698,7 @@
                 <a:ea typeface="Cambria"/>
                 <a:cs typeface="Cambria"/>
               </a:rPr>
-              <a:t>The Madhyasth reply—and its burden</a:t>
+              <a:t>The proposed joint form</a:t>
             </a:r>
           </a:p>
         </p:txBody>
@@ -10519,7 +10754,7 @@
                 <a:ea typeface="Calibri"/>
                 <a:cs typeface="Calibri"/>
               </a:rPr>
-              <a:t>The proposal is joint activity, not an external force. But naming a joint form is not yet a causal account; conditions, pathways, and discriminating observations are still needed.</a:t>
+              <a:t>The sources describe brain–jeevan coordination through signals. A causal account still needs measurable conditions, pathways, and observations that separate it from rivals.</a:t>
             </a:r>
           </a:p>
         </p:txBody>
@@ -10970,7 +11205,7 @@
                 <a:ea typeface="Calibri"/>
                 <a:cs typeface="Calibri"/>
               </a:rPr>
-              <a:t>SCIENCE · LIMITS OF THE INFERENCE</a:t>
+              <a:t>THE ARGUMENT BEYOND REDUCTION</a:t>
             </a:r>
           </a:p>
         </p:txBody>
@@ -11023,7 +11258,7 @@
                 <a:ea typeface="Cambria"/>
                 <a:cs typeface="Cambria"/>
               </a:rPr>
-              <a:t>What Science Explains—and What Remains Open</a:t>
+              <a:t>Why Experience Needs Explanation</a:t>
             </a:r>
           </a:p>
         </p:txBody>
@@ -11290,7 +11525,7 @@
                 <a:ea typeface="Cambria"/>
                 <a:cs typeface="Cambria"/>
               </a:rPr>
-              <a:t>Neural dependence is strong</a:t>
+              <a:t>Experience and its explanation</a:t>
             </a:r>
           </a:p>
         </p:txBody>
@@ -11346,7 +11581,7 @@
                 <a:ea typeface="Calibri"/>
                 <a:cs typeface="Calibri"/>
               </a:rPr>
-              <a:t>Lesions, stimulation, drugs, development, and imaging show that experience and cognition vary systematically with brain and body.</a:t>
+              <a:t>Neural accounts explain mechanisms. The further question is why any such activity has a felt point of view.</a:t>
             </a:r>
           </a:p>
         </p:txBody>
@@ -11613,7 +11848,7 @@
                 <a:ea typeface="Cambria"/>
                 <a:cs typeface="Cambria"/>
               </a:rPr>
-              <a:t>Explanatory entailment is open</a:t>
+              <a:t>Unity, reasons, and value</a:t>
             </a:r>
           </a:p>
         </p:txBody>
@@ -11669,7 +11904,7 @@
                 <a:ea typeface="Calibri"/>
                 <a:cs typeface="Calibri"/>
               </a:rPr>
-              <a:t>Dependence does not yet explain why physical processing is accompanied by experience, nor how reasons and values become causally effective.</a:t>
+              <a:t>A theory must explain one experienced world and beliefs guided by reasons. These demands do not yet identify an enduring bearer.</a:t>
             </a:r>
           </a:p>
         </p:txBody>
@@ -11780,7 +12015,7 @@
                 <a:ea typeface="Calibri"/>
                 <a:cs typeface="Calibri"/>
               </a:rPr>
-              <a:t>The hard problem and the Madhyasth rahasyata both mark an explanatory gap; naming the gap does not decide what fills it.</a:t>
+              <a:t>MD treats mystery as removable through understanding. The hard problem asks why physical activity is experienced at all.</a:t>
             </a:r>
           </a:p>
         </p:txBody>
@@ -11836,7 +12071,7 @@
                 <a:ea typeface="Calibri"/>
                 <a:cs typeface="Calibri"/>
               </a:rPr>
-              <a:t>MD offers jeevan where physicalism demands mechanism. Physicalism offers brain dependence where MD owes discriminating evidence. Each presses where the other is least complete.</a:t>
+              <a:t>Physicalists offer identity, self-models, and accounts of reasoning. Each proposal must explain the same experience and meet the evidence.</a:t>
             </a:r>
           </a:p>
         </p:txBody>
@@ -11889,7 +12124,7 @@
                 <a:ea typeface="Calibri"/>
                 <a:cs typeface="Calibri"/>
               </a:rPr>
-              <a:t>Study §2.4–2.5 · §5.2</a:t>
+              <a:t>Study §4.2–4.5 · §2.5 · COGITATE Consortium 2025</a:t>
             </a:r>
           </a:p>
         </p:txBody>
@@ -14466,7 +14701,7 @@
                 <a:ea typeface="Calibri"/>
                 <a:cs typeface="Calibri"/>
               </a:rPr>
-              <a:t>Does understanding reliably produce justice, trust, responsibility, and mutual fulfilment—and distinguish the theory from rival psychological or ethical accounts?</a:t>
+              <a:t>Do learners show lasting gains in justice and mutual fulfilment? This tests practical understanding. Atomic constitution and survival require further evidence.</a:t>
             </a:r>
           </a:p>
         </p:txBody>
@@ -15504,7 +15739,7 @@
                 <a:ea typeface="Calibri"/>
                 <a:cs typeface="Calibri"/>
               </a:rPr>
-              <a:t>Body + plural jeevan in joint form</a:t>
+              <a:t>Body + one jeevan in joint form</a:t>
             </a:r>
           </a:p>
         </p:txBody>
@@ -19266,7 +19501,7 @@
                 <a:ea typeface="Calibri"/>
                 <a:cs typeface="Calibri"/>
               </a:rPr>
-              <a:t>MD joins physicalism in affirming a real shared world and joins Advaita in rejecting reduction of awareness to matter—but its ontology is not a compromise.</a:t>
+              <a:t>MD shares a real-world commitment with physicalism and resistance to reducing awareness with Advaita. These overlaps do not themselves support its distinctive claims.</a:t>
             </a:r>
           </a:p>
         </p:txBody>
@@ -19659,7 +19894,7 @@
                 <a:ea typeface="Cambria"/>
                 <a:cs typeface="Cambria"/>
               </a:rPr>
-              <a:t>Each Strong Inside, Vulnerable Outside</a:t>
+              <a:t>Strengths and Unresolved Claims</a:t>
             </a:r>
           </a:p>
         </p:txBody>
@@ -19882,7 +20117,7 @@
                 <a:ea typeface="Calibri"/>
                 <a:cs typeface="Calibri"/>
               </a:rPr>
-              <a:t>Atomic transition, latency, post-death continuity, and body–jeevan causation lack independent, discriminating evidence.</a:t>
+              <a:t>Atomic completion, post-death continuity, and body–jeevan coordination lack independent evidence that distinguishes the proposal from rivals.</a:t>
             </a:r>
           </a:p>
         </p:txBody>
@@ -19993,7 +20228,7 @@
                 <a:ea typeface="Cambria"/>
                 <a:cs typeface="Cambria"/>
               </a:rPr>
-              <a:t>Scientific materialism</a:t>
+              <a:t>Science and physicalism</a:t>
             </a:r>
           </a:p>
         </p:txBody>
@@ -20105,7 +20340,7 @@
                 <a:ea typeface="Calibri"/>
                 <a:cs typeface="Calibri"/>
               </a:rPr>
-              <a:t>Reduction from physical process to subjectivity, normativity, and agency remains unfinished; closure is often assumed rather than measured.</a:t>
+              <a:t>Whether neural explanation exhausts experience remains disputed. Physicalism need not reduce every psychological or social explanation to physics.</a:t>
             </a:r>
           </a:p>
         </p:txBody>
@@ -20668,7 +20903,7 @@
                 <a:ea typeface="Calibri"/>
                 <a:cs typeface="Calibri"/>
               </a:rPr>
-              <a:t>THE BOTTOM LINE</a:t>
+              <a:t>EVIDENCE AND OPEN QUESTIONS</a:t>
             </a:r>
           </a:p>
         </p:txBody>
@@ -20989,7 +21224,7 @@
                 <a:ea typeface="Calibri"/>
                 <a:cs typeface="Calibri"/>
               </a:rPr>
-              <a:t>If controlled neural models predict conscious report, learning, and agency without residue, the motivation for jeevan weakens—but metaphysical identity still does not follow automatically.</a:t>
+              <a:t>If neural models explain experience, learning, and agency, the need for jeevan weakens. Predictive success alone does not prove identity.</a:t>
             </a:r>
           </a:p>
         </p:txBody>
@@ -22190,7 +22425,7 @@
                 <a:ea typeface="Calibri"/>
                 <a:cs typeface="Calibri"/>
               </a:rPr>
-              <a:t>Science maps brain–body dependence; physicalism adds that the person is wholly reducible to physicochemical organisation.</a:t>
+              <a:t>Science maps brain–body dependence. Physicalism holds that the embodied person needs no additional sentient entity.</a:t>
             </a:r>
           </a:p>
         </p:txBody>
@@ -23287,7 +23522,7 @@
                 <a:ea typeface="Cambria"/>
                 <a:cs typeface="Cambria"/>
               </a:rPr>
-              <a:t>Same Human Experience, Three Explanatory Commitments</a:t>
+              <a:t>A Case to Develop, With Claims to Test</a:t>
             </a:r>
           </a:p>
         </p:txBody>
@@ -23773,7 +24008,7 @@
                 <a:ea typeface="Calibri"/>
                 <a:cs typeface="Calibri"/>
               </a:rPr>
-              <a:t>Locates identity in nondual awareness and treats the world as dependently real; the witness-to-Brahman step carries the heaviest philosophical burden.</a:t>
+              <a:t>Locates identity in nondual awareness and treats the world as dependently real; identifying the witness with Brahman requires further support.</a:t>
             </a:r>
           </a:p>
         </p:txBody>
@@ -23829,7 +24064,8 @@
                 <a:ea typeface="Calibri"/>
                 <a:cs typeface="Calibri"/>
               </a:rPr>
-              <a:t>Keep the phenomenological data fixed, separate evidence from inference, and ask which ontology explains more with fewer unsupported commitments.</a:t>
+              <a:t>Experience, unity, and reasons motivate the case beyond reduction.
+Whether they require jeevan remains the question to test.</a:t>
             </a:r>
           </a:p>
         </p:txBody>
@@ -24649,7 +24885,7 @@
                 <a:ea typeface="Calibri"/>
                 <a:cs typeface="Calibri"/>
               </a:rPr>
-              <a:t>Examine body + jeevan, the four orders, and the proposed conduct-based test.</a:t>
+              <a:t>Examine body + jeevan, the four orders, and verification through understanding and conduct.</a:t>
             </a:r>
           </a:p>
         </p:txBody>
@@ -25681,7 +25917,7 @@
                 <a:ea typeface="Calibri"/>
                 <a:cs typeface="Calibri"/>
               </a:rPr>
-              <a:t>Phenomenology identifies the explananda; it does not by itself prove jeevan.</a:t>
+              <a:t>These experiences need explanation. They do not alone identify their bearer.</a:t>
             </a:r>
           </a:p>
         </p:txBody>
@@ -26271,7 +26507,7 @@
                 <a:ea typeface="Cambria"/>
                 <a:cs typeface="Cambria"/>
               </a:rPr>
-              <a:t>Wanting outruns need</a:t>
+              <a:t>Continuous fulfilment</a:t>
             </a:r>
           </a:p>
         </p:txBody>
@@ -26327,7 +26563,7 @@
                 <a:ea typeface="Calibri"/>
                 <a:cs typeface="Calibri"/>
               </a:rPr>
-              <a:t>Human desire can become indefinite—wealth, status, certainty, happiness. This exceeds immediate need but can be explained in more than one way.</a:t>
+              <a:t>MD distinguishes recurring bodily needs from the wish for lasting happiness. Endless acquisition is one response to that wish.</a:t>
             </a:r>
           </a:p>
         </p:txBody>
@@ -26650,7 +26886,7 @@
                 <a:ea typeface="Calibri"/>
                 <a:cs typeface="Calibri"/>
               </a:rPr>
-              <a:t>We speak of ‘my body’ and persist through sleep, growth, and change. That raises a continuity question; it does not yet establish a non-material substance.</a:t>
+              <a:t>We experience personal continuity through bodily change. Remembering that continuity is different from showing uninterrupted awareness through sleep.</a:t>
             </a:r>
           </a:p>
         </p:txBody>
@@ -26973,7 +27209,7 @@
                 <a:ea typeface="Calibri"/>
                 <a:cs typeface="Calibri"/>
               </a:rPr>
-              <a:t>Children show expectations of fairness and care early. Developmental evidence constrains explanations; it does not settle whether the source is innate, social, or jeevan.</a:t>
+              <a:t>MD proposes an inherent orientation to justice. Early social responses invite study; they do not yet establish a universal moral understanding at birth.</a:t>
             </a:r>
           </a:p>
         </p:txBody>
@@ -27530,7 +27766,7 @@
                 <a:ea typeface="Cambria"/>
                 <a:cs typeface="Cambria"/>
               </a:rPr>
-              <a:t>Two fulfilments remain embodied</a:t>
+              <a:t>Helping depends on brain function</a:t>
             </a:r>
           </a:p>
         </p:txBody>
@@ -27586,7 +27822,7 @@
                 <a:ea typeface="Calibri"/>
                 <a:cs typeface="Calibri"/>
               </a:rPr>
-              <a:t>Interoception, reward, attachment, and cultural learning can differentiate bodily and relational fulfilment without a second entity.</a:t>
+              <a:t>People with damage to a particular frontal brain region were less willing to make an effort for others. The difference was selective.</a:t>
             </a:r>
           </a:p>
         </p:txBody>
@@ -27694,7 +27930,7 @@
                 <a:ea typeface="Cambria"/>
                 <a:cs typeface="Cambria"/>
               </a:rPr>
-              <a:t>Unlimited wanting is learnable</a:t>
+              <a:t>Desire and ongoing goals</a:t>
             </a:r>
           </a:p>
         </p:txBody>
@@ -27750,7 +27986,7 @@
                 <a:ea typeface="Calibri"/>
                 <a:cs typeface="Calibri"/>
               </a:rPr>
-              <a:t>Reinforcement, prediction, language, and social comparison can extend desire far beyond immediate biological need.</a:t>
+              <a:t>Learning, prediction, language, and social comparison offer accounts of goals that continue beyond immediate bodily need.</a:t>
             </a:r>
           </a:p>
         </p:txBody>
@@ -27858,7 +28094,7 @@
                 <a:ea typeface="Cambria"/>
                 <a:cs typeface="Cambria"/>
               </a:rPr>
-              <a:t>The self is modelled</a:t>
+              <a:t>Bodily selfhood can change</a:t>
             </a:r>
           </a:p>
         </p:txBody>
@@ -27914,7 +28150,7 @@
                 <a:ea typeface="Calibri"/>
                 <a:cs typeface="Calibri"/>
               </a:rPr>
-              <a:t>Memory, embodied prediction, and social cognition can sustain a coherent self-model across bodily change.</a:t>
+              <a:t>Brain stimulation can alter the felt location and perspective of the self. This constrains any account of body and subject.</a:t>
             </a:r>
           </a:p>
         </p:txBody>
@@ -28022,7 +28258,7 @@
                 <a:ea typeface="Cambria"/>
                 <a:cs typeface="Cambria"/>
               </a:rPr>
-              <a:t>Morality develops early</a:t>
+              <a:t>Early social responses</a:t>
             </a:r>
           </a:p>
         </p:txBody>
@@ -28078,7 +28314,7 @@
                 <a:ea typeface="Calibri"/>
                 <a:cs typeface="Calibri"/>
               </a:rPr>
-              <a:t>Evolution, temperament, attachment, and learning can produce early fairness expectations without assuming jeevan.</a:t>
+              <a:t>Some newborns look longer at helpful actions. Other large infant studies find no reliable helper preference. The tasks differ.</a:t>
             </a:r>
           </a:p>
         </p:txBody>
@@ -28189,7 +28425,7 @@
                 <a:ea typeface="Calibri"/>
                 <a:cs typeface="Calibri"/>
               </a:rPr>
-              <a:t>Public evidence shows neural dependence. It has not yet derived subjective experience, normativity, or agency from physics alone.</a:t>
+              <a:t>These findings strongly constrain a theory of the person. Their interpretation must distinguish what was measured from what is inferred.</a:t>
             </a:r>
           </a:p>
         </p:txBody>
@@ -28242,7 +28478,7 @@
                 <a:ea typeface="Calibri"/>
                 <a:cs typeface="Calibri"/>
               </a:rPr>
-              <a:t>Study §2.1–2.5</a:t>
+              <a:t>Lockwood et al. 2024 · Lyu et al. 2023 · Geraci et al. 2025 · Lucca et al. 2025 · Study §2.2</a:t>
             </a:r>
           </a:p>
         </p:txBody>
@@ -28961,7 +29197,7 @@
                 <a:ea typeface="Calibri"/>
                 <a:cs typeface="Calibri"/>
               </a:rPr>
-              <a:t>Fulfilment, wanting, and ego are observed and therefore not the ultimate Self. Deep sleep is recalled as an absence of differentiated experience; Advaita reads it with waking and dream as evidence across states.</a:t>
+              <a:t>Advaita treats fulfilment, wanting, and ego as witnessed contents. It reads waking, dream, and deep sleep as pointing to continuing awareness; later recollection alone does not establish that claim.</a:t>
             </a:r>
           </a:p>
         </p:txBody>
@@ -29395,7 +29631,7 @@
                 <a:ea typeface="Calibri"/>
                 <a:cs typeface="Calibri"/>
               </a:rPr>
-              <a:t>Advaita regards jeevan as still an observable individual principle; MD regards the enduring self and plural world as real. The dispute is where negation should stop.</a:t>
+              <a:t>On this comparison, Advaita would question a separate enduring jeevan; MD affirms individual selves and a real plural world. Their uses of kosha are distinct.</a:t>
             </a:r>
           </a:p>
         </p:txBody>
@@ -31152,7 +31388,7 @@
                 <a:ea typeface="Calibri"/>
                 <a:cs typeface="Calibri"/>
               </a:rPr>
-              <a:t>MD describes four compositional orders. Animal and knowledge orders are sentient because a body is joined with jeevan; ‘order’ names organisation and activity, not four substances nested inside one another.</a:t>
+              <a:t>MD distinguishes four orders by their organisation, activity, and conduct. Animal and knowledge orders are joint forms of body and jeevan; they are not four substances nested inside one another.</a:t>
             </a:r>
           </a:p>
         </p:txBody>
@@ -32044,7 +32280,7 @@
                 <a:ea typeface="Calibri"/>
                 <a:cs typeface="Calibri"/>
               </a:rPr>
-              <a:t>Human body + jeevan; conduct is the central test.</a:t>
+              <a:t>Human body + jeevan; understanding can be expressed in conduct.</a:t>
             </a:r>
           </a:p>
         </p:txBody>
@@ -32765,7 +33001,7 @@
                 <a:ea typeface="Calibri"/>
                 <a:cs typeface="Calibri"/>
               </a:rPr>
-              <a:t>Atomic effort</a:t>
+              <a:t>Evolving atom</a:t>
             </a:r>
           </a:p>
         </p:txBody>
@@ -32926,7 +33162,7 @@
                 <a:ea typeface="Calibri"/>
                 <a:cs typeface="Calibri"/>
               </a:rPr>
-              <a:t>Atomic motion</a:t>
+              <a:t>Particle exchange</a:t>
             </a:r>
           </a:p>
         </p:txBody>
@@ -33087,7 +33323,7 @@
                 <a:ea typeface="Calibri"/>
                 <a:cs typeface="Calibri"/>
               </a:rPr>
-              <a:t>Compositional result</a:t>
+              <a:t>Closed constitution</a:t>
             </a:r>
           </a:p>
         </p:txBody>
@@ -33248,7 +33484,7 @@
                 <a:ea typeface="Calibri"/>
                 <a:cs typeface="Calibri"/>
               </a:rPr>
-              <a:t>Constitutional completion</a:t>
+              <a:t>Sentient jeevan</a:t>
             </a:r>
           </a:p>
         </p:txBody>
@@ -33571,7 +33807,7 @@
                 <a:ea typeface="Calibri"/>
                 <a:cs typeface="Calibri"/>
               </a:rPr>
-              <a:t>Jeevan is claimed to be a constitutionally complete atom with irreducible powers of desire, thought, and expectation.</a:t>
+              <a:t>At constitutional completion, particle exchange is said to cease and sentience to become permanent. Jeevan bears desire, thought, and expectation.</a:t>
             </a:r>
           </a:p>
         </p:txBody>
@@ -33838,7 +34074,7 @@
                 <a:ea typeface="Cambria"/>
                 <a:cs typeface="Cambria"/>
               </a:rPr>
-              <a:t>Latency</a:t>
+              <a:t>What remains unmeasured</a:t>
             </a:r>
           </a:p>
         </p:txBody>
@@ -33894,7 +34130,7 @@
                 <a:ea typeface="Calibri"/>
                 <a:cs typeface="Calibri"/>
               </a:rPr>
-              <a:t>A jeevan not joined to a suitable body is inferred to remain inactive or latent. This protects continuity but is not independently observed.</a:t>
+              <a:t>The sources give no public procedure for identifying this closed constitution or measuring its coordination with a brain.</a:t>
             </a:r>
           </a:p>
         </p:txBody>

</xml_diff>

<commit_message>
Connect human understanding with responsible participation in coexistence
</commit_message>
<xml_diff>
--- a/Studies/Why-Humans-Are-Not-Just-Material/Why-Humans-Are-Not-Just-Material.pptx
+++ b/Studies/Why-Humans-Are-Not-Just-Material/Why-Humans-Are-Not-Just-Material.pptx
@@ -2,32 +2,32 @@
 <file path=ppt/presentation.xml><?xml version="1.0" encoding="utf-8"?>
 <p:presentation xmlns:p="http://schemas.openxmlformats.org/presentationml/2006/main">
   <p:sldMasterIdLst>
-    <p:sldMasterId xmlns:r="http://schemas.openxmlformats.org/officeDocument/2006/relationships" id="2147483648" r:id="R2fa9d1eeec7942ca"/>
+    <p:sldMasterId xmlns:r="http://schemas.openxmlformats.org/officeDocument/2006/relationships" id="2147483648" r:id="Rd5daf91291014816"/>
   </p:sldMasterIdLst>
   <p:notesMasterIdLst>
-    <p:notesMasterId xmlns:r="http://schemas.openxmlformats.org/officeDocument/2006/relationships" r:id="Reb5cbde876594e4b"/>
+    <p:notesMasterId xmlns:r="http://schemas.openxmlformats.org/officeDocument/2006/relationships" r:id="Raf53cf4bb5c143cd"/>
   </p:notesMasterIdLst>
   <p:sldIdLst>
-    <p:sldId xmlns:r="http://schemas.openxmlformats.org/officeDocument/2006/relationships" id="256" r:id="R6cc567e189ca4888"/>
-    <p:sldId xmlns:r="http://schemas.openxmlformats.org/officeDocument/2006/relationships" id="257" r:id="R260ffa3e65824cba"/>
-    <p:sldId xmlns:r="http://schemas.openxmlformats.org/officeDocument/2006/relationships" id="258" r:id="Rbf27793d33c541e5"/>
-    <p:sldId xmlns:r="http://schemas.openxmlformats.org/officeDocument/2006/relationships" id="259" r:id="R6a6d53fab529485f"/>
-    <p:sldId xmlns:r="http://schemas.openxmlformats.org/officeDocument/2006/relationships" id="260" r:id="Rd8d70905973a4e10"/>
-    <p:sldId xmlns:r="http://schemas.openxmlformats.org/officeDocument/2006/relationships" id="261" r:id="Rcdbeb37bed4046dc"/>
-    <p:sldId xmlns:r="http://schemas.openxmlformats.org/officeDocument/2006/relationships" id="262" r:id="Rc674a5af32e44ca0"/>
-    <p:sldId xmlns:r="http://schemas.openxmlformats.org/officeDocument/2006/relationships" id="263" r:id="R469d39412f504a2a"/>
-    <p:sldId xmlns:r="http://schemas.openxmlformats.org/officeDocument/2006/relationships" id="264" r:id="R8b5cef126dfb4910"/>
-    <p:sldId xmlns:r="http://schemas.openxmlformats.org/officeDocument/2006/relationships" id="265" r:id="R2e0f587d4e304672"/>
-    <p:sldId xmlns:r="http://schemas.openxmlformats.org/officeDocument/2006/relationships" id="266" r:id="R403c16e972254c46"/>
-    <p:sldId xmlns:r="http://schemas.openxmlformats.org/officeDocument/2006/relationships" id="267" r:id="R30bc1274c24847bf"/>
-    <p:sldId xmlns:r="http://schemas.openxmlformats.org/officeDocument/2006/relationships" id="268" r:id="R54d440ec340c4c79"/>
-    <p:sldId xmlns:r="http://schemas.openxmlformats.org/officeDocument/2006/relationships" id="269" r:id="R2b5c1557bca240af"/>
-    <p:sldId xmlns:r="http://schemas.openxmlformats.org/officeDocument/2006/relationships" id="270" r:id="R7ecc506d5adf496d"/>
-    <p:sldId xmlns:r="http://schemas.openxmlformats.org/officeDocument/2006/relationships" id="271" r:id="Rd46bcd89cdc44ef4"/>
-    <p:sldId xmlns:r="http://schemas.openxmlformats.org/officeDocument/2006/relationships" id="272" r:id="Rbf60e6f92b164f8b"/>
-    <p:sldId xmlns:r="http://schemas.openxmlformats.org/officeDocument/2006/relationships" id="273" r:id="Ra495a86748df40ea"/>
-    <p:sldId xmlns:r="http://schemas.openxmlformats.org/officeDocument/2006/relationships" id="274" r:id="Rf9d5b2b90cb94ed6"/>
-    <p:sldId xmlns:r="http://schemas.openxmlformats.org/officeDocument/2006/relationships" id="275" r:id="R97069bd4ece54f0d"/>
+    <p:sldId xmlns:r="http://schemas.openxmlformats.org/officeDocument/2006/relationships" id="256" r:id="Rec77f1b58fe0405f"/>
+    <p:sldId xmlns:r="http://schemas.openxmlformats.org/officeDocument/2006/relationships" id="257" r:id="R4ab31770f63d4032"/>
+    <p:sldId xmlns:r="http://schemas.openxmlformats.org/officeDocument/2006/relationships" id="258" r:id="R481727ef285b41c4"/>
+    <p:sldId xmlns:r="http://schemas.openxmlformats.org/officeDocument/2006/relationships" id="259" r:id="R2ed8c931749b4eb9"/>
+    <p:sldId xmlns:r="http://schemas.openxmlformats.org/officeDocument/2006/relationships" id="260" r:id="R8800b43ea70946eb"/>
+    <p:sldId xmlns:r="http://schemas.openxmlformats.org/officeDocument/2006/relationships" id="261" r:id="Rb50c75ac083340e1"/>
+    <p:sldId xmlns:r="http://schemas.openxmlformats.org/officeDocument/2006/relationships" id="262" r:id="R3d67d21f9fd649b3"/>
+    <p:sldId xmlns:r="http://schemas.openxmlformats.org/officeDocument/2006/relationships" id="263" r:id="R07198ae4ed194b92"/>
+    <p:sldId xmlns:r="http://schemas.openxmlformats.org/officeDocument/2006/relationships" id="264" r:id="R3c50aa4dc3834a1a"/>
+    <p:sldId xmlns:r="http://schemas.openxmlformats.org/officeDocument/2006/relationships" id="265" r:id="Ra618c0a1dc8e4f6d"/>
+    <p:sldId xmlns:r="http://schemas.openxmlformats.org/officeDocument/2006/relationships" id="266" r:id="Rb90705bf32f14175"/>
+    <p:sldId xmlns:r="http://schemas.openxmlformats.org/officeDocument/2006/relationships" id="267" r:id="Ra24b8827bad04479"/>
+    <p:sldId xmlns:r="http://schemas.openxmlformats.org/officeDocument/2006/relationships" id="268" r:id="R250a3ce21feb4f8b"/>
+    <p:sldId xmlns:r="http://schemas.openxmlformats.org/officeDocument/2006/relationships" id="269" r:id="R071654ccf6224b73"/>
+    <p:sldId xmlns:r="http://schemas.openxmlformats.org/officeDocument/2006/relationships" id="270" r:id="R4c9518324a4d4e52"/>
+    <p:sldId xmlns:r="http://schemas.openxmlformats.org/officeDocument/2006/relationships" id="271" r:id="Rc814190dc0154da3"/>
+    <p:sldId xmlns:r="http://schemas.openxmlformats.org/officeDocument/2006/relationships" id="272" r:id="R4122424098f34dfb"/>
+    <p:sldId xmlns:r="http://schemas.openxmlformats.org/officeDocument/2006/relationships" id="273" r:id="Ree880f9cfd904253"/>
+    <p:sldId xmlns:r="http://schemas.openxmlformats.org/officeDocument/2006/relationships" id="274" r:id="R13a7b6a38f684afb"/>
+    <p:sldId xmlns:r="http://schemas.openxmlformats.org/officeDocument/2006/relationships" id="275" r:id="Re9a940b5639047d4"/>
   </p:sldIdLst>
   <p:sldSz cx="12191695" cy="6858000"/>
   <p:notesSz cx="6858000" cy="9144000"/>
@@ -744,7 +744,7 @@
           <a:lstStyle xmlns:a="http://schemas.openxmlformats.org/drawingml/2006/main"/>
           <a:p xmlns:a="http://schemas.openxmlformats.org/drawingml/2006/main">
             <a:r>
-              <a:t>The sources describe coordination through signals, but the study has no measured model of those signals. Calling the relation a joint form does not specify how a difference in jeevan produces a difference in neural activity. A useful account must relate its proposed states to observable bodily effects and say how its predictions differ from those of an embodied neural account.</a:t>
+              <a:t>The sources describe coordination through signals, but the study has no measured model of those signals. Calling the relation a joint form does not specify how a difference in jeevan produces a difference in neural activity. A useful account must relate its proposed states to observable bodily effects and say how its predictions differ from those of an embodied neural account. It must explain apparent changes in valuation and motivation as well as failures to carry out an intact intention.</a:t>
             </a:r>
           </a:p>
           <a:p xmlns:a="http://schemas.openxmlformats.org/drawingml/2006/main">
@@ -834,7 +834,7 @@
           <a:lstStyle xmlns:a="http://schemas.openxmlformats.org/drawingml/2006/main"/>
           <a:p xmlns:a="http://schemas.openxmlformats.org/drawingml/2006/main">
             <a:r>
-              <a:t>Here is the affirmative philosophical case. A description of neural mechanisms can explain discrimination, access, memory, and report while still leaving the question of why there is a felt experience. The knowledge argument sharpens this: if someone acquires every physical fact about colour and later sees red, have they learned a further fact, or gained a new ability or way of encountering a fact? The physicalist reply needs to answer that question; the argument does not simply settle it.</a:t>
+              <a:t>A description of neural mechanisms can explain discrimination, memory, and report while leaving the question of why there is felt experience. Experience also presents a world whose contents belong together. A theory must explain this unity, although integration through distributed processes remains a serious possibility.</a:t>
             </a:r>
           </a:p>
           <a:p xmlns:a="http://schemas.openxmlformats.org/drawingml/2006/main">
@@ -844,7 +844,7 @@
           </a:p>
           <a:p xmlns:a="http://schemas.openxmlformats.org/drawingml/2006/main">
             <a:r>
-              <a:t>Experience also presents a world whose contents belong together. This places a demand on a theory of the subject. It does not establish an indivisible atom: integration might be realised through distributed and changing processes. Finally, people assess whether beliefs follow from reasons and actions answer to values. A causal explanation needs room for those distinctions. Naturalistic accounts of learning, error correction, and reasoning are serious replies, not the claim that reasoning is blind motion. These considerations motivate going beyond an account that omits experience; moving from them to a specific jeevan needs further argument.</a:t>
+              <a:t>Human beings can question their aims and recognise what relationships require. For example, a business might increase its returns while damaging water on which its workers, neighbours, and future activity depend. Its narrow measure of success leaves out those relationships. This illustrates the problem of pursuing gain without understanding its conditions. It does not show that every local activity causes collapse.</a:t>
             </a:r>
           </a:p>
           <a:p xmlns:a="http://schemas.openxmlformats.org/drawingml/2006/main">
@@ -854,7 +854,7 @@
           </a:p>
           <a:p xmlns:a="http://schemas.openxmlformats.org/drawingml/2006/main">
             <a:r>
-              <a:t>COGITATE's 2025 adversarial study tested specified predictions of integrated information theory and global neuronal workspace theory in 256 participants. Its mixed results challenged parts of both theories; they did not reject every neural explanation or establish a nonmaterial bearer. MD's claim that mystery can be removed through understanding is distinct from this debate's hard problem.</a:t>
+              <a:t>Madhyasth Darshan connects awakening with guiding pleasure, health, and gain through justice, dharma, and truth. Satya concerns reality as coexistence. Dharma concerns what is inherent in beings and their participation in order. Nyaya involves recognising relationships, fulfilling their values, evaluating that fulfilment, and mutual satisfaction. Anubhav is realised understanding of coexistence. That understanding informs resolve and thought and guides action. The aim is humane fulfilment, which requires more than the survival of an organisation.</a:t>
             </a:r>
           </a:p>
           <a:p xmlns:a="http://schemas.openxmlformats.org/drawingml/2006/main">
@@ -864,7 +864,17 @@
           </a:p>
           <a:p xmlns:a="http://schemas.openxmlformats.org/drawingml/2006/main">
             <a:r>
-              <a:t>Sources: Chalmers (2003), https://consc.net/papers/nature.html ; Bayne and Chalmers (2003), https://consc.net/papers/unity.html ; Graziano (2024), https://pmc.ncbi.nlm.nih.gov/articles/PMC11521794/ ; COGITATE Consortium (2025), https://www.nature.com/articles/s41586-025-08888-1 . See study §§4.2–4.5 and 2.5.</a:t>
+              <a:t>A physicalist can explain wider understanding through embodied learning and social life. Local feedback can support collective order, and people can cooperate without anyone knowing every detail of the whole. Ostrom’s research on shared resources supports the importance of communication and shared rules. Understanding a wider world does not alone prove a physically separate knower. The further question is whether an embodied account fully explains experience and the recognition that reasons should guide us.</a:t>
+            </a:r>
+          </a:p>
+          <a:p xmlns:a="http://schemas.openxmlformats.org/drawingml/2006/main">
+            <a:r>
+              <a:t/>
+            </a:r>
+          </a:p>
+          <a:p xmlns:a="http://schemas.openxmlformats.org/drawingml/2006/main">
+            <a:r>
+              <a:t>Sources: MVD, printed pp. 97–100 and 336 (same PDF positions); JV, printed pp. 138–139 (PDF positions 139–140); Ostrom (2010), https://www.aeaweb.org/articles?id=10.1257/aer.100.3.641 ; Chalmers (2003), https://consc.net/papers/nature.html ; Bayne and Chalmers (2003), https://consc.net/papers/unity.html . See study §§4.2–4.5.</a:t>
             </a:r>
           </a:p>
         </p:txBody>
@@ -1274,7 +1284,7 @@
           <a:lstStyle xmlns:a="http://schemas.openxmlformats.org/drawingml/2006/main"/>
           <a:p xmlns:a="http://schemas.openxmlformats.org/drawingml/2006/main">
             <a:r>
-              <a:t>The views face different burdens and do not have equal evidential standing simply because none settles every question. Madhyasth Darshan gives a connected account of experience, understanding, conduct, and coexistence. Its distinctive atomic, causal, and survival commitments need evidence beyond textual agreement or practical benefit. Internal coherence itself must be examined, especially the relation between the transition to sentience and the permanent character subsequently attributed to it.</a:t>
+              <a:t>The views face different burdens and do not have equal evidential standing simply because none settles every question. Madhyasth Darshan gives a connected account of experience, understanding, conduct, and coexistence. Awakening makes the knower’s recognition of relationships central to how aims are chosen and fulfilled. Practical success in cooperation can support the value of this learning without by itself establishing a separate sentient unit. Its distinctive atomic, causal, and survival commitments need evidence beyond textual agreement or practical benefit. Internal coherence itself must be examined, especially the relation between the transition to sentience and the permanent character subsequently attributed to it.</a:t>
             </a:r>
           </a:p>
           <a:p xmlns:a="http://schemas.openxmlformats.org/drawingml/2006/main">
@@ -1514,7 +1524,7 @@
           <a:lstStyle xmlns:a="http://schemas.openxmlformats.org/drawingml/2006/main"/>
           <a:p xmlns:a="http://schemas.openxmlformats.org/drawingml/2006/main">
             <a:r>
-              <a:t>The title keeps the study's affirmative motivation. Human experience, the unity of an experienced world, and the responsiveness of belief and action to reasons are substantial things to explain. They give a reason to resist treating a description of bodily machinery as the whole answer before the explanation is supplied.</a:t>
+              <a:t>The title keeps the study’s affirmative motivation. Human experience, the unity of an experienced world, and the responsiveness of belief and action to reasons are substantial things to explain. Understanding our place in a shared world adds to this case by connecting experience with our capacity to question our aims and fulfil relationships.</a:t>
             </a:r>
           </a:p>
           <a:p xmlns:a="http://schemas.openxmlformats.org/drawingml/2006/main">
@@ -1524,7 +1534,17 @@
           </a:p>
           <a:p xmlns:a="http://schemas.openxmlformats.org/drawingml/2006/main">
             <a:r>
-              <a:t>Madhyasth Darshan offers a distinctive positive account: a real sentient individual in a real shared world, living through a body and capable of understanding and responsible conduct. The stronger conclusion that this requires an enduring, constitutionally complete jeevan remains a proposal to develop and test. Current neuroscience supplies evidence that any such account must explain; it does not by itself answer every metaphysical question. The next step is to sharpen the argument and identify the observations that would support or weaken each of its claims. See study §§4.5 and 5.4.</a:t>
+              <a:t>Madhyasth Darshan offers a distinctive account: a real sentient individual in a real shared world, living through a body and capable of awakening. Realised understanding of coexistence gives direction to thought and conduct. This is a positive role for jeevan, beyond filling a gap in a neural explanation.</a:t>
+            </a:r>
+          </a:p>
+          <a:p xmlns:a="http://schemas.openxmlformats.org/drawingml/2006/main">
+            <a:r>
+              <a:t/>
+            </a:r>
+          </a:p>
+          <a:p xmlns:a="http://schemas.openxmlformats.org/drawingml/2006/main">
+            <a:r>
+              <a:t>The need for a wider understanding supports the importance of awakening more directly than it establishes how jeevan first arose. The further conclusion that human life requires an enduring, constitutionally complete jeevan remains a proposal to develop and test. Current neuroscience supplies evidence that any such account must explain. Embodied learning and cooperation also offer explanations of wider understanding that the argument must address. See study §§4.4–4.5 and 5.4.</a:t>
             </a:r>
           </a:p>
         </p:txBody>
@@ -1684,7 +1704,7 @@
           </a:p>
           <a:p xmlns:a="http://schemas.openxmlformats.org/drawingml/2006/main">
             <a:r>
-              <a:t>The experienced distinction between “I” and “my body” raises a question about the self. A continuing person through sleep does not automatically mean uninterrupted reportable experience. Likewise, the source's proposal of an inherent orientation to justice needs to be distinguished from what developmental experiments measure. Early attention to social actions is narrower than understanding justice, and neither by itself identifies jeevan.</a:t>
+              <a:t>Pleasure, health, and gain are the perspectives of priya, hita, and labha. Pleasure concerns sensory gratification, health concerns bodily nourishment, and acquisitive gain concerns receiving more value than one gives. Awakening brings these concerns under the guidance of justice, dharma, and truth. Prosperity replaces accumulation for its own sake. What changes is the understanding of fulfilment and the aims one considers reasonable.</a:t>
             </a:r>
           </a:p>
           <a:p xmlns:a="http://schemas.openxmlformats.org/drawingml/2006/main">
@@ -1694,7 +1714,17 @@
           </a:p>
           <a:p xmlns:a="http://schemas.openxmlformats.org/drawingml/2006/main">
             <a:r>
-              <a:t>Sources: Samadhanatmak Bhautikvad (SB), PDF pp. 15 and 91–92; Jeevan Vidya—An Introduction (JV), printed pp. 24–27 (PDF positions 25–28). Study §1.2 supplies the connected account; §§2.2 and 4 examine alternative explanations and the further argument.</a:t>
+              <a:t>The experienced distinction between “I” and “my body” raises a question about the self. A continuing person through sleep does not automatically mean uninterrupted reportable experience. Likewise, an inherent orientation to justice differs from what developmental experiments measure. Early attention to social actions is narrower than understanding justice, and neither by itself identifies jeevan.</a:t>
+            </a:r>
+          </a:p>
+          <a:p xmlns:a="http://schemas.openxmlformats.org/drawingml/2006/main">
+            <a:r>
+              <a:t/>
+            </a:r>
+          </a:p>
+          <a:p xmlns:a="http://schemas.openxmlformats.org/drawingml/2006/main">
+            <a:r>
+              <a:t>Sources: Samadhanatmak Bhautikvad (SB), PDF pp. 15 and 91–92; Jeevan Vidya—An Introduction (JV), printed pp. 24–27 and 138–139 (PDF positions 25–28 and 139–140); Madhyasth Darshan Vangmaya (MVD), printed pp. 58 and 66 (same PDF positions). See study §§1.2, 2.2 and 4.4.</a:t>
             </a:r>
           </a:p>
         </p:txBody>
@@ -1764,7 +1794,7 @@
           <a:lstStyle xmlns:a="http://schemas.openxmlformats.org/drawingml/2006/main"/>
           <a:p xmlns:a="http://schemas.openxmlformats.org/drawingml/2006/main">
             <a:r>
-              <a:t>These examples show why the evidence must enter the argument in detail. Lockwood and colleagues studied 25 people with damage to the ventromedial prefrontal cortex alongside lesion and healthy comparison groups. Willingness to exert effort for others was reduced selectively. This is evidence about a component of prosocial motivation, not the disappearance of all value or moral judgement. Lyu and colleagues found that stimulation of the anterior precuneus could alter bodily self-experience in nine patients. Such selective changes constrain a body–jeevan account as well as a physicalist one.</a:t>
+              <a:t>These examples show why the evidence must enter the argument in detail. Lockwood and colleagues studied 25 people with damage to the ventromedial prefrontal cortex alongside lesion and healthy comparison groups. Willingness to exert effort for others was reduced selectively. The account must explain apparent changes in what a person values and is motivated to do, as well as difficulties in carrying out an otherwise intact intention. These choices do not directly establish that inner concern disappeared, or that all value and moral judgement were lost. Lyu and colleagues found that stimulation of the anterior precuneus could alter bodily self-experience in nine patients. Such selective changes constrain a body–jeevan account as well as a physicalist one.</a:t>
             </a:r>
           </a:p>
           <a:p xmlns:a="http://schemas.openxmlformats.org/drawingml/2006/main">
@@ -1774,7 +1804,7 @@
           </a:p>
           <a:p xmlns:a="http://schemas.openxmlformats.org/drawingml/2006/main">
             <a:r>
-              <a:t>Formal models of learning and active inference offer possible accounts of ongoing goals. They do not establish that all aspirations to lasting happiness have been explained. Geraci and colleagues found a preference for prosocial actions in newborn looking behaviour; the large ManyBabies study reported no reliable helper preference in older infants on a different task. The latter is not a direct replication of the newborn study. Neither finding establishes an entire moral doctrine at birth.</a:t>
+              <a:t>Formal models of learning and active inference offer possible accounts of ongoing goals. Regulation can anticipate future needs, so activity continues when no immediate deficit is felt. These models do not establish that every aspiration to lasting happiness has been explained. Geraci and colleagues found a preference for prosocial actions in newborn looking behaviour. The large ManyBabies study reported no reliable helper preference in older infants on a different task. Neither finding establishes an entire moral doctrine at birth.</a:t>
             </a:r>
           </a:p>
           <a:p xmlns:a="http://schemas.openxmlformats.org/drawingml/2006/main">
@@ -1944,7 +1974,7 @@
           <a:lstStyle xmlns:a="http://schemas.openxmlformats.org/drawingml/2006/main"/>
           <a:p xmlns:a="http://schemas.openxmlformats.org/drawingml/2006/main">
             <a:r>
-              <a:t>Madhyasth Darshan places the human within a real coexistence of physical, chemical, and jeevan units in Omnipresence. The human body and jeevan form a temporary joint form. The body composes and decomposes; jeevan is said to retain its constitution and capacity for sentience. Sensation and action occur through the embodied joint form, while understanding and evaluation are attributed to jeevan.</a:t>
+              <a:t>Madhyasth Darshan places the human within a real coexistence of physical, chemical, and jeevan units in Omnipresence. The body and jeevan form a temporary joint form. The body composes and decomposes. Jeevan retains its constitution and capacity for sentience. Sensation and action occur through the embodied joint form, while understanding and evaluation belong to jeevan.</a:t>
             </a:r>
           </a:p>
           <a:p xmlns:a="http://schemas.openxmlformats.org/drawingml/2006/main">
@@ -1954,7 +1984,7 @@
           </a:p>
           <a:p xmlns:a="http://schemas.openxmlformats.org/drawingml/2006/main">
             <a:r>
-              <a:t>This is an affirmative account with commitments of its own, including atomic completion, coordination with a body, and continued existence after bodily death. The claim should be understood as a whole before it is tested. Calling it a sentient atom does not by itself identify it with an atom as defined and measured in present physics. Jeevan Vidya expressly calls jeevan neither physical nor non-physical, but a constitutionally complete sentient atom.</a:t>
+              <a:t>Awakening gives this account its direction in human life. Realisation of coexistence informs understanding, resolve, and thought, and finds expression in the recognition and fulfilment of relationships. Jeevan can therefore examine what it seeks, instead of only pursuing an existing aim more efficiently. The need for such understanding speaks most directly to awakening. Animals and unawakened humans already involve jeevan in this account. Constitutional completion and awakening answer different developmental questions.</a:t>
             </a:r>
           </a:p>
           <a:p xmlns:a="http://schemas.openxmlformats.org/drawingml/2006/main">
@@ -1964,7 +1994,17 @@
           </a:p>
           <a:p xmlns:a="http://schemas.openxmlformats.org/drawingml/2006/main">
             <a:r>
-              <a:t>Sources: Madhyasth Darshan Vangmaya (MVD), The Alternative, point 7, printed p. 5 (PDF position 5), for the displayed quotation; JV, printed p. 36 (PDF position 37). See study §§1.1 and 1.3.</a:t>
+              <a:t>These commitments include atomic completion, coordination with a body, and continued existence after bodily death. Calling jeevan a sentient atom does not identify it with an atom as measured in present physics. The source describes a unit with constituent particles, whose relationship to known physical atoms remains to be established. Jeevan Vidya calls it neither physical nor non-physical, but a constitutionally complete sentient atom.</a:t>
+            </a:r>
+          </a:p>
+          <a:p xmlns:a="http://schemas.openxmlformats.org/drawingml/2006/main">
+            <a:r>
+              <a:t/>
+            </a:r>
+          </a:p>
+          <a:p xmlns:a="http://schemas.openxmlformats.org/drawingml/2006/main">
+            <a:r>
+              <a:t>Sources: MVD, The Alternative, point 7, printed p. 5, for the displayed quotation; printed pp. 27, 78 and 97–100 (same PDF positions); JV, printed p. 36 (PDF position 37). See study §§1.1 and 1.3.</a:t>
             </a:r>
           </a:p>
         </p:txBody>
@@ -2034,7 +2074,7 @@
           <a:lstStyle xmlns:a="http://schemas.openxmlformats.org/drawingml/2006/main"/>
           <a:p xmlns:a="http://schemas.openxmlformats.org/drawingml/2006/main">
             <a:r>
-              <a:t>The four orders are distinguished by their characteristic activities and conduct. Material formations compose and decompose. Biological formations grow and reproduce. Animal life is described as a joint form of body and jeevan, with sensitivity and a hope to live. The knowledge order is the human joint form, capable of understanding existence and expressing that understanding in responsible conduct.</a:t>
+              <a:t>The four orders are distinguished by their characteristic activities and conduct. Material formations compose and decompose. Biological formations grow and reproduce. Animal life is a joint form of body and jeevan, with sensitivity and a hope to live. The knowledge order is the human joint form, capable of understanding existence and expressing that understanding in responsible conduct.</a:t>
             </a:r>
           </a:p>
           <a:p xmlns:a="http://schemas.openxmlformats.org/drawingml/2006/main">
@@ -2044,7 +2084,7 @@
           </a:p>
           <a:p xmlns:a="http://schemas.openxmlformats.org/drawingml/2006/main">
             <a:r>
-              <a:t>The classification is not a claim that four substances are stacked inside the human. Nor is the order sequence by itself a measured evolutionary explanation of how jeevan first appears. Compositional development of bodies and constitutional development of an atom do different work in the account. The human brain is the bodily medium for the expression of understanding; knowledge here must not be confused with a newly acquired capacity for any sentience at all.</a:t>
+              <a:t>Material, biological, and animal nature already display orderliness through their characteristic forms of conformance. Awakened humans participate through responsible production, use, and nurture of nature. They do not supply the laws that make nature function. Their understanding concerns how to fulfil their own participation in coexistence.</a:t>
             </a:r>
           </a:p>
           <a:p xmlns:a="http://schemas.openxmlformats.org/drawingml/2006/main">
@@ -2054,7 +2094,17 @@
           </a:p>
           <a:p xmlns:a="http://schemas.openxmlformats.org/drawingml/2006/main">
             <a:r>
-              <a:t>Sources: SB, PDF pp. 179–180; MVD, printed pp. 91 and 115–116 (same PDF positions). See study §§1.3.1 and 1.3.4.</a:t>
+              <a:t>The classification is not a claim that four substances are stacked inside the human. The order sequence alone does not provide a measured evolutionary explanation of jeevan’s origin. Compositional development of bodies and constitutional development of an atom do different work in the account. The human brain is the bodily medium for expressing understanding. Awakening develops that understanding within an already sentient jeevan.</a:t>
+            </a:r>
+          </a:p>
+          <a:p xmlns:a="http://schemas.openxmlformats.org/drawingml/2006/main">
+            <a:r>
+              <a:t/>
+            </a:r>
+          </a:p>
+          <a:p xmlns:a="http://schemas.openxmlformats.org/drawingml/2006/main">
+            <a:r>
+              <a:t>Sources: SB, PDF pp. 179–180 and 236–237; MVD, printed pp. 27, 91 and 115–116 (same PDF positions). See study §§1.3.1 and 1.3.4.</a:t>
             </a:r>
           </a:p>
         </p:txBody>
@@ -2134,7 +2184,7 @@
           </a:p>
           <a:p xmlns:a="http://schemas.openxmlformats.org/drawingml/2006/main">
             <a:r>
-              <a:t>The presentation does not add an explanation in which latent sentience becomes actual, or assert that an unembodied jeevan is inactive. Those additions do not resolve the transition described in the texts. Freedom from weight bondage has not been operationally identified with zero rest mass. The source's 122 activities in paired faculty groups also do not by themselves establish a 61-particle constitution. Atomic constitution, persistence, and its coordination with a brain each require a way to distinguish the proposal from alternative accounts. Study §5 sets out those evidential requirements.</a:t>
+              <a:t>The presentation does not add an explanation in which latent sentience becomes actual, or assert that an unembodied jeevan is inactive. Those additions do not resolve the transition described in the texts. The source describes a nucleus and orbiting particles, so a stable constitution does not mean a unit without constituents. Its relationship to atoms recognised in contemporary physics remains to be established. Freedom from weight bondage has not been operationally identified with zero rest mass. The source's 122 activities in paired faculty groups also do not by themselves establish a 61-particle constitution. Atomic constitution, persistence, and its coordination with a brain each require a way to distinguish the proposal from alternative accounts. Study §5 sets out those evidential requirements.</a:t>
             </a:r>
           </a:p>
           <a:p xmlns:a="http://schemas.openxmlformats.org/drawingml/2006/main">
@@ -5100,17 +5150,17 @@
   </p:cSld>
   <p:clrMap bg1="lt1" tx1="dk1" bg2="lt2" tx2="dk2" accent1="accent1" accent2="accent2" accent3="accent3" accent4="accent4" accent5="accent5" accent6="accent6" hlink="hlink" folHlink="folHlink"/>
   <p:sldLayoutIdLst>
-    <p:sldLayoutId xmlns:r="http://schemas.openxmlformats.org/officeDocument/2006/relationships" id="2147483649" r:id="Rfe240fa849074ddc"/>
-    <p:sldLayoutId xmlns:r="http://schemas.openxmlformats.org/officeDocument/2006/relationships" id="2147483650" r:id="Rc0c09e65f90344e9"/>
-    <p:sldLayoutId xmlns:r="http://schemas.openxmlformats.org/officeDocument/2006/relationships" id="2147483651" r:id="R17a70069d6874338"/>
-    <p:sldLayoutId xmlns:r="http://schemas.openxmlformats.org/officeDocument/2006/relationships" id="2147483652" r:id="Rc1b009e74c014a28"/>
-    <p:sldLayoutId xmlns:r="http://schemas.openxmlformats.org/officeDocument/2006/relationships" id="2147483653" r:id="R00bd2ec3bc4d4bb5"/>
-    <p:sldLayoutId xmlns:r="http://schemas.openxmlformats.org/officeDocument/2006/relationships" id="2147483654" r:id="R9ed214aeb51e4ee0"/>
-    <p:sldLayoutId xmlns:r="http://schemas.openxmlformats.org/officeDocument/2006/relationships" id="2147483655" r:id="Rfbfb9806a6834862"/>
-    <p:sldLayoutId xmlns:r="http://schemas.openxmlformats.org/officeDocument/2006/relationships" id="2147483656" r:id="Rb47eb73b54aa4ab3"/>
-    <p:sldLayoutId xmlns:r="http://schemas.openxmlformats.org/officeDocument/2006/relationships" id="2147483657" r:id="Re6af7382f8ad4660"/>
-    <p:sldLayoutId xmlns:r="http://schemas.openxmlformats.org/officeDocument/2006/relationships" id="2147483658" r:id="R6326a2798ba64623"/>
-    <p:sldLayoutId xmlns:r="http://schemas.openxmlformats.org/officeDocument/2006/relationships" id="2147483659" r:id="R69f6e68d52c345c6"/>
+    <p:sldLayoutId xmlns:r="http://schemas.openxmlformats.org/officeDocument/2006/relationships" id="2147483649" r:id="R4139a2b5b4494b9a"/>
+    <p:sldLayoutId xmlns:r="http://schemas.openxmlformats.org/officeDocument/2006/relationships" id="2147483650" r:id="Rac05cb213814401f"/>
+    <p:sldLayoutId xmlns:r="http://schemas.openxmlformats.org/officeDocument/2006/relationships" id="2147483651" r:id="R8ffc4698425d402f"/>
+    <p:sldLayoutId xmlns:r="http://schemas.openxmlformats.org/officeDocument/2006/relationships" id="2147483652" r:id="Re4f4c2ea96f34df4"/>
+    <p:sldLayoutId xmlns:r="http://schemas.openxmlformats.org/officeDocument/2006/relationships" id="2147483653" r:id="Rfe644b8381584272"/>
+    <p:sldLayoutId xmlns:r="http://schemas.openxmlformats.org/officeDocument/2006/relationships" id="2147483654" r:id="Reb8b4fb7f7964115"/>
+    <p:sldLayoutId xmlns:r="http://schemas.openxmlformats.org/officeDocument/2006/relationships" id="2147483655" r:id="Ra20469fa03024ce5"/>
+    <p:sldLayoutId xmlns:r="http://schemas.openxmlformats.org/officeDocument/2006/relationships" id="2147483656" r:id="R0ab7cc6563a547dd"/>
+    <p:sldLayoutId xmlns:r="http://schemas.openxmlformats.org/officeDocument/2006/relationships" id="2147483657" r:id="R89946c98d5f94d08"/>
+    <p:sldLayoutId xmlns:r="http://schemas.openxmlformats.org/officeDocument/2006/relationships" id="2147483658" r:id="R4d2c9e243c634067"/>
+    <p:sldLayoutId xmlns:r="http://schemas.openxmlformats.org/officeDocument/2006/relationships" id="2147483659" r:id="R4e1ba03a61e944a9"/>
   </p:sldLayoutIdLst>
   <p:txStyles>
     <p:titleStyle>
@@ -11258,7 +11308,7 @@
                 <a:ea typeface="Cambria"/>
                 <a:cs typeface="Cambria"/>
               </a:rPr>
-              <a:t>Why Experience Needs Explanation</a:t>
+              <a:t>Experience, Understanding, and Conduct</a:t>
             </a:r>
           </a:p>
         </p:txBody>
@@ -11525,7 +11575,7 @@
                 <a:ea typeface="Cambria"/>
                 <a:cs typeface="Cambria"/>
               </a:rPr>
-              <a:t>Experience and its explanation</a:t>
+              <a:t>Experience and unity</a:t>
             </a:r>
           </a:p>
         </p:txBody>
@@ -11581,7 +11631,7 @@
                 <a:ea typeface="Calibri"/>
                 <a:cs typeface="Calibri"/>
               </a:rPr>
-              <a:t>Neural accounts explain mechanisms. The further question is why any such activity has a felt point of view.</a:t>
+              <a:t>A theory must explain why neural activity has a felt point of view, and how its contents form one experienced world. Integration alone does not identify an indivisible bearer.</a:t>
             </a:r>
           </a:p>
         </p:txBody>
@@ -11848,7 +11898,7 @@
                 <a:ea typeface="Cambria"/>
                 <a:cs typeface="Cambria"/>
               </a:rPr>
-              <a:t>Unity, reasons, and value</a:t>
+              <a:t>Understanding and conduct</a:t>
             </a:r>
           </a:p>
         </p:txBody>
@@ -11904,7 +11954,7 @@
                 <a:ea typeface="Calibri"/>
                 <a:cs typeface="Calibri"/>
               </a:rPr>
-              <a:t>A theory must explain one experienced world and beliefs guided by reasons. These demands do not yet identify an enduring bearer.</a:t>
+              <a:t>Jeevan can examine its aims and recognise what relationships require. Realising coexistence gives direction to thought and action. Efficient acquisition alone does not settle fulfilment.</a:t>
             </a:r>
           </a:p>
         </p:txBody>
@@ -12015,7 +12065,29 @@
                 <a:ea typeface="Calibri"/>
                 <a:cs typeface="Calibri"/>
               </a:rPr>
-              <a:t>MD treats mystery as removable through understanding. The hard problem asks why physical activity is experienced at all.</a:t>
+              <a:t>Satya concerns coexistence, dharma concerns innateness and order, and nyaya concerns the </a:t>
+            </a:r>
+            <a:r>
+              <a:rPr sz="1450" b="1" i="0">
+                <a:solidFill>
+                  <a:srgbClr val="FFFFFF"/>
+                </a:solidFill>
+                <a:latin typeface="Calibri"/>
+                <a:ea typeface="Calibri"/>
+                <a:cs typeface="Calibri"/>
+              </a:rPr>
+              <a:t>mutual fulfilment of relationships</a:t>
+            </a:r>
+            <a:r>
+              <a:rPr sz="1450" b="1" i="0">
+                <a:solidFill>
+                  <a:srgbClr val="FFFFFF"/>
+                </a:solidFill>
+                <a:latin typeface="Calibri"/>
+                <a:ea typeface="Calibri"/>
+                <a:cs typeface="Calibri"/>
+              </a:rPr>
+              <a:t>.</a:t>
             </a:r>
           </a:p>
         </p:txBody>
@@ -12071,7 +12143,7 @@
                 <a:ea typeface="Calibri"/>
                 <a:cs typeface="Calibri"/>
               </a:rPr>
-              <a:t>Physicalists offer identity, self-models, and accounts of reasoning. Each proposal must explain the same experience and meet the evidence.</a:t>
+              <a:t>Embodied learning can also support a wider understanding. Its breadth alone does not prove a knower beyond physical processes.</a:t>
             </a:r>
           </a:p>
         </p:txBody>
@@ -12124,7 +12196,7 @@
                 <a:ea typeface="Calibri"/>
                 <a:cs typeface="Calibri"/>
               </a:rPr>
-              <a:t>Study §4.2–4.5 · §2.5 · COGITATE Consortium 2025</a:t>
+              <a:t>Study §4.2–4.5 · MVD pp. 97–100, 336 · JV pp. 138–139</a:t>
             </a:r>
           </a:p>
         </p:txBody>
@@ -20061,7 +20133,7 @@
                 <a:ea typeface="Calibri"/>
                 <a:cs typeface="Calibri"/>
               </a:rPr>
-              <a:t>Integrates self, value, conduct, and nature in one system; offers a public-facing ideal of verification.</a:t>
+              <a:t>Connects the knower’s understanding of coexistence with examining its aims and fulfilling relationships in conduct.</a:t>
             </a:r>
           </a:p>
         </p:txBody>
@@ -23846,7 +23918,7 @@
                 <a:ea typeface="Calibri"/>
                 <a:cs typeface="Calibri"/>
               </a:rPr>
-              <a:t>Proposes a real body + jeevan joint form and makes conduct central; its atomic and causal claims remain open to stronger tests.</a:t>
+              <a:t>Identifies jeevan as the knower whose awakening guides conduct in coexistence. Its constitution and relation to the body need further evidence.</a:t>
             </a:r>
           </a:p>
         </p:txBody>
@@ -26563,7 +26635,7 @@
                 <a:ea typeface="Calibri"/>
                 <a:cs typeface="Calibri"/>
               </a:rPr>
-              <a:t>MD distinguishes recurring bodily needs from the wish for lasting happiness. Endless acquisition is one response to that wish.</a:t>
+              <a:t>MD connects lasting fulfilment with guiding pleasure, health, and gain through justice, dharma, and truth. Acquisition alone cannot provide this understanding.</a:t>
             </a:r>
           </a:p>
         </p:txBody>
@@ -27986,7 +28058,7 @@
                 <a:ea typeface="Calibri"/>
                 <a:cs typeface="Calibri"/>
               </a:rPr>
-              <a:t>Learning, prediction, language, and social comparison offer accounts of goals that continue beyond immediate bodily need.</a:t>
+              <a:t>Learning and prediction offer accounts of ongoing goals. Regulation can anticipate future needs even when no immediate deficit is felt.</a:t>
             </a:r>
           </a:p>
         </p:txBody>
@@ -30614,7 +30686,7 @@
                 <a:ea typeface="Cambria"/>
                 <a:cs typeface="Cambria"/>
               </a:rPr>
-              <a:t>A model, not a gap-filler</a:t>
+              <a:t>The knower and its conduct</a:t>
             </a:r>
           </a:p>
         </p:txBody>
@@ -30670,7 +30742,7 @@
                 <a:ea typeface="Calibri"/>
                 <a:cs typeface="Calibri"/>
               </a:rPr>
-              <a:t>The body supplies structure and physiological activity; jeevan is proposed to account for experience, appraisal, desire, and understanding. The distinction still requires evidence.</a:t>
+              <a:t>The body provides the organs and neural medium. Jeevan bears experience and evaluation. Through awakening, it understands coexistence and guides conduct through that understanding.</a:t>
             </a:r>
           </a:p>
         </p:txBody>
@@ -30939,7 +31011,7 @@
                 <a:ea typeface="Calibri"/>
                 <a:cs typeface="Calibri"/>
               </a:rPr>
-              <a:t>Matter develops through compositional orders; jeevan is claimed to arise through a distinct atomic completion. These are separate claims.</a:t>
+              <a:t>Constitutional completion concerns the emergence of sentience. Awakening concerns how jeevan understands and fulfils its relationships.</a:t>
             </a:r>
           </a:p>
         </p:txBody>

</xml_diff>